<commit_message>
Refresh the 1.1.0 document-pair edition
Regenerate and publish the manager/engineering presentation and narrative for
the 1.1.0 cut. Correct the catalog surface counts to 9 languages, 5 build
systems and 9 package providers (adds TypeScript, Zig, Elixir, repo-man,
Cargo, npm and ZIP), and relabel the private repository's planned 1.2.0
edition as 1.1.0, since that work ships together in the first public release.

Co-Authored-By: Claude Opus 5.5 <noreply@anthropic.com>
</commit_message>
<xml_diff>
--- a/docs/presentations/literate-ai-manager-overview/literate-ai-manager-and-engineering-overview.pptx
+++ b/docs/presentations/literate-ai-manager-overview/literate-ai-manager-and-engineering-overview.pptx
@@ -1522,7 +1522,7 @@
           </a:p>
           <a:p>
             <a:r>
-              <a:t>ADR 0034 adds a Python-owned contribution sweep and authenticated document-pair preflight for every major or minor cut. This slide does not claim v1.2.0 is already published.</a:t>
+              <a:t>ADR 0034 adds a Python-owned contribution sweep and authenticated document-pair preflight for every major or minor cut. This slide does not claim v1.1.0 is already published.</a:t>
             </a:r>
           </a:p>
           <a:p>
@@ -1772,7 +1772,7 @@
           <a:lstStyle/>
           <a:p>
             <a:r>
-              <a:t>The implemented 1.1 native-custody and 1.0 operator/release boundaries remain. 1.2 adds dependency-aware bounded scheduling, cache authority, real local Debian construction, native CLI and gRPC acceptance, and canonical worktree placement.</a:t>
+              <a:t>Native custody and the 1.0 operator/release boundaries remain. 1.1 adds dependency-aware bounded scheduling, cache authority, real local Debian construction, native CLI and gRPC acceptance, and canonical worktree placement.</a:t>
             </a:r>
           </a:p>
           <a:p>
@@ -1922,7 +1922,7 @@
           <a:lstStyle/>
           <a:p>
             <a:r>
-              <a:t>This is the decision slide. The requested outcome is production-hardening investment plus selection of the first downstream 1.2 production adoption.</a:t>
+              <a:t>This is the decision slide. The requested outcome is production-hardening investment plus selection of the first downstream 1.1 production adoption.</a:t>
             </a:r>
           </a:p>
           <a:p>
@@ -2147,12 +2147,12 @@
           <a:lstStyle/>
           <a:p>
             <a:r>
-              <a:t>Current matrix: Python 3.11+, C++17, Rust 2021, JavaScript/Node 20+, Swift, and Go; Bazel, GNU Make, CMake, and Cargo; macOS, Linux, and Windows Flavors.</a:t>
-            </a:r>
-          </a:p>
-          <a:p>
-            <a:r>
-              <a:t>Packaging Flavors are pip, Conan, apt, Homebrew, WinGet, and Chocolatey. Multi-provider planning is implemented; native application-package construction and independent verification are live for pip wheels and Conan cache archives.</a:t>
+              <a:t>Current matrix: Python 3.11+, C++17, Rust 2021, JavaScript/Node 20+, TypeScript, Swift, Go, Zig, and Elixir/OTP 27+; Bazel, GNU Make, CMake, Cargo, and repo-man; macOS, Linux, and Windows Flavors.</a:t>
+            </a:r>
+          </a:p>
+          <a:p>
+            <a:r>
+              <a:t>Packaging Flavors are pip, Conan, apt, Homebrew, WinGet, Chocolatey, Cargo, npm, and ZIP. Multi-provider planning is implemented; native application-package construction and independent verification are live for pip wheels and Conan cache archives.</a:t>
             </a:r>
           </a:p>
           <a:p>
@@ -25318,7 +25318,7 @@
                 </a:solidFill>
                 <a:latin typeface="Helvetica Neue"/>
               </a:rPr>
-              <a:t>1.2 overlaps exact work and reuses only verified bytes.</a:t>
+              <a:t>1.1 overlaps exact work and reuses only verified bytes.</a:t>
             </a:r>
           </a:p>
         </p:txBody>
@@ -25925,7 +25925,7 @@
                 </a:solidFill>
                 <a:latin typeface="Helvetica Neue"/>
               </a:rPr>
-              <a:t>1.2 candidate slices; production dispatch, LAN proof, and remote package custody remain open.</a:t>
+              <a:t>1.1 slices; production dispatch, LAN proof, and remote package custody remain open.</a:t>
             </a:r>
           </a:p>
         </p:txBody>
@@ -26741,7 +26741,7 @@
                 </a:solidFill>
                 <a:latin typeface="Helvetica Neue"/>
               </a:rPr>
-              <a:t>Take one demanding downstream application through installed 1.2 scheduling, cache, package, and native acceptance, then invest in production operations.</a:t>
+              <a:t>Take one demanding downstream application through installed 1.1 scheduling, cache, package, and native acceptance, then invest in production operations.</a:t>
             </a:r>
           </a:p>
         </p:txBody>
@@ -27202,7 +27202,7 @@
                 </a:solidFill>
                 <a:latin typeface="Helvetica Neue"/>
               </a:rPr>
-              <a:t>Decision: fund hardening and select one 1.2 production adopter.</a:t>
+              <a:t>Decision: fund hardening and select one 1.1 production adopter.</a:t>
             </a:r>
           </a:p>
         </p:txBody>
@@ -29062,7 +29062,7 @@
                 </a:solidFill>
                 <a:latin typeface="Helvetica Neue"/>
               </a:rPr>
-              <a:t>6</a:t>
+              <a:t>9</a:t>
             </a:r>
           </a:p>
         </p:txBody>
@@ -29176,7 +29176,7 @@
                 </a:solidFill>
                 <a:latin typeface="Helvetica Neue"/>
               </a:rPr>
-              <a:t>4</a:t>
+              <a:t>5</a:t>
             </a:r>
           </a:p>
         </p:txBody>
@@ -29404,7 +29404,7 @@
                 </a:solidFill>
                 <a:latin typeface="Helvetica Neue"/>
               </a:rPr>
-              <a:t>6</a:t>
+              <a:t>9</a:t>
             </a:r>
           </a:p>
         </p:txBody>

</xml_diff>

<commit_message>
Regenerate the 1.2.0 document-pair edition
Revalidate the factual ledger against the merged 1.2 line and regenerate the
manager/engineering presentation and narrative for the 1.2.0 minor cut.
Correct the release gate count to 15 (public-export-check) and the build-system
Flavor count to six (build-mix); package providers stay nine, with Hex recorded
as a build-mix toolchain constraint and pinned dependency input rather than a
provider. Revise slide 23 and add a narrative 8.1.3 section for bounded
candidate repair, cross-host action workers and the standard receiver,
Elixir/Mix, and forge-default coordination, keeping #2 and #4 deferred to 1.3.
Local acceptance passes all 11 scenarios (26 slides, 73 headings); Google
publication is pending.

Co-Authored-By: Claude Opus 5.5 <noreply@anthropic.com>
</commit_message>
<xml_diff>
--- a/docs/presentations/literate-ai-manager-overview/literate-ai-manager-and-engineering-overview.pptx
+++ b/docs/presentations/literate-ai-manager-overview/literate-ai-manager-and-engineering-overview.pptx
@@ -1257,7 +1257,7 @@
           </a:p>
           <a:p>
             <a:r>
-              <a:t>Package plan is read-only. Package build reruns the accepted Standard lifecycle before constructing selected pip/Conan bytes beneath OBJ_DIR; package verify independently reopens them. None of these verbs publishes.</a:t>
+              <a:t>Package plan is read-only. Package build reruns the accepted Standard lifecycle before constructing selected pip, Conan, or local Debian bytes beneath OBJ_DIR; package verify independently reopens them. None of these verbs publishes.</a:t>
             </a:r>
           </a:p>
           <a:p>
@@ -1342,7 +1342,7 @@
           </a:p>
           <a:p>
             <a:r>
-              <a:t>Gate names abbreviated for slide width; the real 14-gate list is repository-layout-check, python-check, lint, format-check, openspec-check, documentation-check, driver-review, skills-check, installed-e2e, wheel-check, install-check, installed-project-e2e, samples, test-receipt-current (see the Makefile's RELEASE_GATES). There is no codegraph-ready gate.</a:t>
+              <a:t>Gate names abbreviated for slide width; the real 15-gate list is repository-layout-check, public-export-check, python-check, lint, format-check, openspec-check, documentation-check, driver-review, skills-check, installed-e2e, wheel-check, install-check, installed-project-e2e, samples, test-receipt-current (see the Makefile's RELEASE_GATES). There is no codegraph-ready gate.</a:t>
             </a:r>
           </a:p>
           <a:p>
@@ -1522,12 +1522,17 @@
           </a:p>
           <a:p>
             <a:r>
-              <a:t>ADR 0034 adds a Python-owned contribution sweep and authenticated document-pair preflight for every major or minor cut. This slide does not claim v1.1.0 is already published.</a:t>
+              <a:t>ADR 0034 adds a Python-owned contribution sweep and authenticated document-pair preflight for every major or minor cut. This slide does not claim v1.2.0 is already published.</a:t>
             </a:r>
           </a:p>
           <a:p>
             <a:r>
               <a:t>Gate target selection remains local worker fleet or GitHub Actions with the same declared gate; GitLab is recognized but fail-closed, and a single legacy-local VM remains complete when no fleet is configured.</a:t>
+            </a:r>
+          </a:p>
+          <a:p>
+            <a:r>
+              <a:t>1.2 requires an explicit SemVer release policy. When the policy declares qualification, release check defaults to a tiered target: each platform x action cell is covered by the host running the coding CLI, then one workers.json worker per remaining platform, then CI; litai release qualify records exact-HEAD coverage.</a:t>
             </a:r>
           </a:p>
         </p:txBody>
@@ -1772,12 +1777,32 @@
           <a:lstStyle/>
           <a:p>
             <a:r>
-              <a:t>Native custody and the 1.0 operator/release boundaries remain. 1.1 adds dependency-aware bounded scheduling, cache authority, real local Debian construction, native CLI and gRPC acceptance, and canonical worktree placement.</a:t>
-            </a:r>
-          </a:p>
-          <a:p>
-            <a:r>
-              <a:t>These are bounded implemented slices. Production command and SSH composition, measured real LAN warm-cache hits, remote native-package custody, complete native-CLI lifecycle proof, and audited legacy-worktree retirement remain follow-on work.</a:t>
+              <a:t>The 1.1 foundation remains: dependency-aware bounded scheduling, provider-neutral cache authority, real local Debian construction, native CLI and gRPC acceptance, and canonical worktree placement, plus native custody and the 1.0 operator/release boundaries.</a:t>
+            </a:r>
+          </a:p>
+          <a:p>
+            <a:r>
+              <a:t>REPAIR: litai rebuild turns a retryable build or generated-test rejection into up to two fresh replacement candidates, each a durable attempt chained to the rejected one. The conformance sample runner retains a bounded, redacted diagnostic excerpt and feeds it to the next attempt. Authority: src/literate_ai/adapters/candidate_repair.py and tests/conformance/support/sample_runner.py.</a:t>
+            </a:r>
+          </a:p>
+          <a:p>
+            <a:r>
+              <a:t>DISTRIBUTE: when BUILD, TEST, EXECUTE and FINALIZE all run on admitted workers, rebuild derives toolchain identities, commands and native dependencies from the worker; python -m literate_ai.standard_receiver is the reference receiver for portable single-Component Make/Python projects. Production FINALIZE grant provisioning remains pending.</a:t>
+            </a:r>
+          </a:p>
+          <a:p>
+            <a:r>
+              <a:t>BUILD: the build-mix Flavor pins each Hex package's exact version and checksums, refuses ranges, and requires the native lock to equal those pins before compiling. Mix builds are local-only in 1.2. Hex is a toolchain constraint and dependency input, not a package provider.</a:t>
+            </a:r>
+          </a:p>
+          <a:p>
+            <a:r>
+              <a:t>COORDINATE: ADR 0050 makes forge issues and PRs/MRs the default tracker and agent channel; other trackers are overrides. prompt-task@2 is the generic external envelope. Remote live gates no longer require OPENAI_API_KEY.</a:t>
+            </a:r>
+          </a:p>
+          <a:p>
+            <a:r>
+              <a:t>Deferred to 1.3 by maintainer decision: production action-DAG dispatch with multi-worker shared LAN-cache qualification (#4) and clean three-way update merging (#2). Remote native-package custody, complete native-CLI lifecycle proof, and audited legacy-worktree retirement also remain open.</a:t>
             </a:r>
           </a:p>
         </p:txBody>
@@ -1922,7 +1947,7 @@
           <a:lstStyle/>
           <a:p>
             <a:r>
-              <a:t>This is the decision slide. The requested outcome is production-hardening investment plus selection of the first downstream 1.1 production adoption.</a:t>
+              <a:t>This is the decision slide. The requested outcome is production-hardening investment plus selection of the first downstream 1.2 production adoption.</a:t>
             </a:r>
           </a:p>
           <a:p>
@@ -2147,12 +2172,12 @@
           <a:lstStyle/>
           <a:p>
             <a:r>
-              <a:t>Current matrix: Python 3.11+, C++17, Rust 2021, JavaScript/Node 20+, TypeScript, Swift, Go, Zig, and Elixir/OTP 27+; Bazel, GNU Make, CMake, Cargo, and repo-man; macOS, Linux, and Windows Flavors.</a:t>
-            </a:r>
-          </a:p>
-          <a:p>
-            <a:r>
-              <a:t>Packaging Flavors are pip, Conan, apt, Homebrew, WinGet, Chocolatey, Cargo, npm, and ZIP. Multi-provider planning is implemented; native application-package construction and independent verification are live for pip wheels and Conan cache archives.</a:t>
+              <a:t>Current matrix: Python 3.11+, C++17, Rust 2021, JavaScript/Node 20+, TypeScript, Swift, Go, Zig, and Elixir/OTP 27+; Bazel, GNU Make, CMake, Cargo, Mix, and repo-man; macOS, Linux, and Windows Flavors. Mix (build-mix) is new in 1.2.</a:t>
+            </a:r>
+          </a:p>
+          <a:p>
+            <a:r>
+              <a:t>Packaging Flavors are pip, Conan, apt, Homebrew, WinGet, Chocolatey, Cargo, npm, and ZIP. Hex is not a package provider: build-mix carries a Hex toolchain constraint, and Hex packages are checksum-pinned dependency inputs. Multi-provider planning is implemented; native construction and independent verification are live for pip wheels, Conan cache archives, and local Debian packages on compatible Linux hosts.</a:t>
             </a:r>
           </a:p>
           <a:p>
@@ -16870,7 +16895,7 @@
         <p:spPr>
           <a:xfrm>
             <a:off x="666750" y="3009900"/>
-            <a:ext cx="723900" cy="419100"/>
+            <a:ext cx="676275" cy="419100"/>
           </a:xfrm>
           <a:prstGeom prst="roundRect">
             <a:avLst>
@@ -16916,7 +16941,7 @@
         <p:spPr>
           <a:xfrm>
             <a:off x="666750" y="3152775"/>
-            <a:ext cx="723900" cy="190500"/>
+            <a:ext cx="676275" cy="190500"/>
           </a:xfrm>
           <a:prstGeom prst="rect">
             <a:avLst/>
@@ -16950,8 +16975,8 @@
         </p:nvSpPr>
         <p:spPr>
           <a:xfrm>
-            <a:off x="1438275" y="3009900"/>
-            <a:ext cx="723900" cy="419100"/>
+            <a:off x="1390650" y="3009900"/>
+            <a:ext cx="676275" cy="419100"/>
           </a:xfrm>
           <a:prstGeom prst="roundRect">
             <a:avLst>
@@ -16996,8 +17021,8 @@
         </p:nvSpPr>
         <p:spPr>
           <a:xfrm>
-            <a:off x="1438275" y="3152775"/>
-            <a:ext cx="723900" cy="190500"/>
+            <a:off x="1390650" y="3152775"/>
+            <a:ext cx="676275" cy="190500"/>
           </a:xfrm>
           <a:prstGeom prst="rect">
             <a:avLst/>
@@ -17018,7 +17043,7 @@
                 </a:solidFill>
                 <a:latin typeface="Helvetica Neue"/>
               </a:rPr>
-              <a:t>python</a:t>
+              <a:t>export</a:t>
             </a:r>
           </a:p>
         </p:txBody>
@@ -17031,8 +17056,8 @@
         </p:nvSpPr>
         <p:spPr>
           <a:xfrm>
-            <a:off x="2209800" y="3009900"/>
-            <a:ext cx="723900" cy="419100"/>
+            <a:off x="2114550" y="3009900"/>
+            <a:ext cx="676275" cy="419100"/>
           </a:xfrm>
           <a:prstGeom prst="roundRect">
             <a:avLst>
@@ -17077,8 +17102,8 @@
         </p:nvSpPr>
         <p:spPr>
           <a:xfrm>
-            <a:off x="2209800" y="3152775"/>
-            <a:ext cx="723900" cy="190500"/>
+            <a:off x="2114550" y="3152775"/>
+            <a:ext cx="676275" cy="190500"/>
           </a:xfrm>
           <a:prstGeom prst="rect">
             <a:avLst/>
@@ -17099,7 +17124,7 @@
                 </a:solidFill>
                 <a:latin typeface="Helvetica Neue"/>
               </a:rPr>
-              <a:t>lint</a:t>
+              <a:t>python</a:t>
             </a:r>
           </a:p>
         </p:txBody>
@@ -17112,8 +17137,8 @@
         </p:nvSpPr>
         <p:spPr>
           <a:xfrm>
-            <a:off x="2981325" y="3009900"/>
-            <a:ext cx="723900" cy="419100"/>
+            <a:off x="2838450" y="3009900"/>
+            <a:ext cx="676275" cy="419100"/>
           </a:xfrm>
           <a:prstGeom prst="roundRect">
             <a:avLst>
@@ -17158,8 +17183,8 @@
         </p:nvSpPr>
         <p:spPr>
           <a:xfrm>
-            <a:off x="2981325" y="3152775"/>
-            <a:ext cx="723900" cy="190500"/>
+            <a:off x="2838450" y="3152775"/>
+            <a:ext cx="676275" cy="190500"/>
           </a:xfrm>
           <a:prstGeom prst="rect">
             <a:avLst/>
@@ -17180,7 +17205,7 @@
                 </a:solidFill>
                 <a:latin typeface="Helvetica Neue"/>
               </a:rPr>
-              <a:t>format</a:t>
+              <a:t>lint</a:t>
             </a:r>
           </a:p>
         </p:txBody>
@@ -17193,8 +17218,8 @@
         </p:nvSpPr>
         <p:spPr>
           <a:xfrm>
-            <a:off x="3752850" y="3009900"/>
-            <a:ext cx="723900" cy="419100"/>
+            <a:off x="3562350" y="3009900"/>
+            <a:ext cx="676275" cy="419100"/>
           </a:xfrm>
           <a:prstGeom prst="roundRect">
             <a:avLst>
@@ -17239,8 +17264,8 @@
         </p:nvSpPr>
         <p:spPr>
           <a:xfrm>
-            <a:off x="3752850" y="3152775"/>
-            <a:ext cx="723900" cy="190500"/>
+            <a:off x="3562350" y="3152775"/>
+            <a:ext cx="676275" cy="190500"/>
           </a:xfrm>
           <a:prstGeom prst="rect">
             <a:avLst/>
@@ -17261,7 +17286,7 @@
                 </a:solidFill>
                 <a:latin typeface="Helvetica Neue"/>
               </a:rPr>
-              <a:t>openspec</a:t>
+              <a:t>format</a:t>
             </a:r>
           </a:p>
         </p:txBody>
@@ -17274,8 +17299,8 @@
         </p:nvSpPr>
         <p:spPr>
           <a:xfrm>
-            <a:off x="4524375" y="3009900"/>
-            <a:ext cx="723900" cy="419100"/>
+            <a:off x="4286250" y="3009900"/>
+            <a:ext cx="676275" cy="419100"/>
           </a:xfrm>
           <a:prstGeom prst="roundRect">
             <a:avLst>
@@ -17320,8 +17345,8 @@
         </p:nvSpPr>
         <p:spPr>
           <a:xfrm>
-            <a:off x="4524375" y="3152775"/>
-            <a:ext cx="723900" cy="190500"/>
+            <a:off x="4286250" y="3152775"/>
+            <a:ext cx="676275" cy="190500"/>
           </a:xfrm>
           <a:prstGeom prst="rect">
             <a:avLst/>
@@ -17342,7 +17367,7 @@
                 </a:solidFill>
                 <a:latin typeface="Helvetica Neue"/>
               </a:rPr>
-              <a:t>doc-check</a:t>
+              <a:t>openspec</a:t>
             </a:r>
           </a:p>
         </p:txBody>
@@ -17355,8 +17380,8 @@
         </p:nvSpPr>
         <p:spPr>
           <a:xfrm>
-            <a:off x="5295900" y="3009900"/>
-            <a:ext cx="723900" cy="419100"/>
+            <a:off x="5010150" y="3009900"/>
+            <a:ext cx="676275" cy="419100"/>
           </a:xfrm>
           <a:prstGeom prst="roundRect">
             <a:avLst>
@@ -17364,7 +17389,7 @@
             </a:avLst>
           </a:prstGeom>
           <a:solidFill>
-            <a:srgbClr val="F47C7C"/>
+            <a:srgbClr val="7BC6A4"/>
           </a:solidFill>
           <a:ln>
             <a:noFill/>
@@ -17401,8 +17426,8 @@
         </p:nvSpPr>
         <p:spPr>
           <a:xfrm>
-            <a:off x="5295900" y="3152775"/>
-            <a:ext cx="723900" cy="190500"/>
+            <a:off x="5010150" y="3152775"/>
+            <a:ext cx="676275" cy="190500"/>
           </a:xfrm>
           <a:prstGeom prst="rect">
             <a:avLst/>
@@ -17423,7 +17448,7 @@
                 </a:solidFill>
                 <a:latin typeface="Helvetica Neue"/>
               </a:rPr>
-              <a:t>driver</a:t>
+              <a:t>doc-check</a:t>
             </a:r>
           </a:p>
         </p:txBody>
@@ -17436,8 +17461,89 @@
         </p:nvSpPr>
         <p:spPr>
           <a:xfrm>
-            <a:off x="6067425" y="3009900"/>
-            <a:ext cx="723900" cy="419100"/>
+            <a:off x="5734050" y="3009900"/>
+            <a:ext cx="676275" cy="419100"/>
+          </a:xfrm>
+          <a:prstGeom prst="roundRect">
+            <a:avLst>
+              <a:gd name="adj" fmla="val 9000"/>
+            </a:avLst>
+          </a:prstGeom>
+          <a:solidFill>
+            <a:srgbClr val="F47C7C"/>
+          </a:solidFill>
+          <a:ln>
+            <a:noFill/>
+          </a:ln>
+          <a:effectLst/>
+        </p:spPr>
+        <p:style>
+          <a:lnRef idx="1">
+            <a:schemeClr val="accent1"/>
+          </a:lnRef>
+          <a:fillRef idx="3">
+            <a:schemeClr val="accent1"/>
+          </a:fillRef>
+          <a:effectRef idx="2">
+            <a:schemeClr val="accent1"/>
+          </a:effectRef>
+          <a:fontRef idx="minor">
+            <a:schemeClr val="lt1"/>
+          </a:fontRef>
+        </p:style>
+        <p:txBody>
+          <a:bodyPr rtlCol="0" anchor="ctr"/>
+          <a:lstStyle/>
+          <a:p>
+            <a:pPr algn="ctr"/>
+          </a:p>
+        </p:txBody>
+      </p:sp>
+      <p:sp>
+        <p:nvSpPr>
+          <p:cNvPr id="26" name="TextBox 25"/>
+          <p:cNvSpPr txBox="1"/>
+          <p:nvPr/>
+        </p:nvSpPr>
+        <p:spPr>
+          <a:xfrm>
+            <a:off x="5734050" y="3152775"/>
+            <a:ext cx="676275" cy="190500"/>
+          </a:xfrm>
+          <a:prstGeom prst="rect">
+            <a:avLst/>
+          </a:prstGeom>
+          <a:noFill/>
+        </p:spPr>
+        <p:txBody>
+          <a:bodyPr wrap="square" anchor="t" lIns="0" rIns="0" tIns="0" bIns="0">
+            <a:spAutoFit/>
+          </a:bodyPr>
+          <a:lstStyle/>
+          <a:p>
+            <a:pPr algn="ctr"/>
+            <a:r>
+              <a:rPr sz="800" b="1" i="0">
+                <a:solidFill>
+                  <a:srgbClr val="101317"/>
+                </a:solidFill>
+                <a:latin typeface="Helvetica Neue"/>
+              </a:rPr>
+              <a:t>driver</a:t>
+            </a:r>
+          </a:p>
+        </p:txBody>
+      </p:sp>
+      <p:sp>
+        <p:nvSpPr>
+          <p:cNvPr id="27" name="Rounded Rectangle 26"/>
+          <p:cNvSpPr/>
+          <p:nvPr/>
+        </p:nvSpPr>
+        <p:spPr>
+          <a:xfrm>
+            <a:off x="6457950" y="3009900"/>
+            <a:ext cx="676275" cy="419100"/>
           </a:xfrm>
           <a:prstGeom prst="roundRect">
             <a:avLst>
@@ -17478,14 +17584,14 @@
       </p:sp>
       <p:sp>
         <p:nvSpPr>
-          <p:cNvPr id="26" name="TextBox 25"/>
-          <p:cNvSpPr txBox="1"/>
-          <p:nvPr/>
-        </p:nvSpPr>
-        <p:spPr>
-          <a:xfrm>
-            <a:off x="6067425" y="3152775"/>
-            <a:ext cx="723900" cy="190500"/>
+          <p:cNvPr id="28" name="TextBox 27"/>
+          <p:cNvSpPr txBox="1"/>
+          <p:nvPr/>
+        </p:nvSpPr>
+        <p:spPr>
+          <a:xfrm>
+            <a:off x="6457950" y="3152775"/>
+            <a:ext cx="676275" cy="190500"/>
           </a:xfrm>
           <a:prstGeom prst="rect">
             <a:avLst/>
@@ -17513,14 +17619,14 @@
       </p:sp>
       <p:sp>
         <p:nvSpPr>
-          <p:cNvPr id="27" name="Rounded Rectangle 26"/>
+          <p:cNvPr id="29" name="Rounded Rectangle 28"/>
           <p:cNvSpPr/>
           <p:nvPr/>
         </p:nvSpPr>
         <p:spPr>
           <a:xfrm>
-            <a:off x="6838950" y="3009900"/>
-            <a:ext cx="723900" cy="419100"/>
+            <a:off x="7181850" y="3009900"/>
+            <a:ext cx="676275" cy="419100"/>
           </a:xfrm>
           <a:prstGeom prst="roundRect">
             <a:avLst>
@@ -17561,14 +17667,14 @@
       </p:sp>
       <p:sp>
         <p:nvSpPr>
-          <p:cNvPr id="28" name="TextBox 27"/>
-          <p:cNvSpPr txBox="1"/>
-          <p:nvPr/>
-        </p:nvSpPr>
-        <p:spPr>
-          <a:xfrm>
-            <a:off x="6838950" y="3152775"/>
-            <a:ext cx="723900" cy="190500"/>
+          <p:cNvPr id="30" name="TextBox 29"/>
+          <p:cNvSpPr txBox="1"/>
+          <p:nvPr/>
+        </p:nvSpPr>
+        <p:spPr>
+          <a:xfrm>
+            <a:off x="7181850" y="3152775"/>
+            <a:ext cx="676275" cy="190500"/>
           </a:xfrm>
           <a:prstGeom prst="rect">
             <a:avLst/>
@@ -17596,14 +17702,14 @@
       </p:sp>
       <p:sp>
         <p:nvSpPr>
-          <p:cNvPr id="29" name="Rounded Rectangle 28"/>
+          <p:cNvPr id="31" name="Rounded Rectangle 30"/>
           <p:cNvSpPr/>
           <p:nvPr/>
         </p:nvSpPr>
         <p:spPr>
           <a:xfrm>
-            <a:off x="7610475" y="3009900"/>
-            <a:ext cx="723900" cy="419100"/>
+            <a:off x="7905750" y="3009900"/>
+            <a:ext cx="676275" cy="419100"/>
           </a:xfrm>
           <a:prstGeom prst="roundRect">
             <a:avLst>
@@ -17644,14 +17750,14 @@
       </p:sp>
       <p:sp>
         <p:nvSpPr>
-          <p:cNvPr id="30" name="TextBox 29"/>
-          <p:cNvSpPr txBox="1"/>
-          <p:nvPr/>
-        </p:nvSpPr>
-        <p:spPr>
-          <a:xfrm>
-            <a:off x="7610475" y="3152775"/>
-            <a:ext cx="723900" cy="190500"/>
+          <p:cNvPr id="32" name="TextBox 31"/>
+          <p:cNvSpPr txBox="1"/>
+          <p:nvPr/>
+        </p:nvSpPr>
+        <p:spPr>
+          <a:xfrm>
+            <a:off x="7905750" y="3152775"/>
+            <a:ext cx="676275" cy="190500"/>
           </a:xfrm>
           <a:prstGeom prst="rect">
             <a:avLst/>
@@ -17679,14 +17785,14 @@
       </p:sp>
       <p:sp>
         <p:nvSpPr>
-          <p:cNvPr id="31" name="Rounded Rectangle 30"/>
+          <p:cNvPr id="33" name="Rounded Rectangle 32"/>
           <p:cNvSpPr/>
           <p:nvPr/>
         </p:nvSpPr>
         <p:spPr>
           <a:xfrm>
-            <a:off x="8382000" y="3009900"/>
-            <a:ext cx="723900" cy="419100"/>
+            <a:off x="8629650" y="3009900"/>
+            <a:ext cx="676275" cy="419100"/>
           </a:xfrm>
           <a:prstGeom prst="roundRect">
             <a:avLst>
@@ -17727,14 +17833,14 @@
       </p:sp>
       <p:sp>
         <p:nvSpPr>
-          <p:cNvPr id="32" name="TextBox 31"/>
-          <p:cNvSpPr txBox="1"/>
-          <p:nvPr/>
-        </p:nvSpPr>
-        <p:spPr>
-          <a:xfrm>
-            <a:off x="8382000" y="3152775"/>
-            <a:ext cx="723900" cy="190500"/>
+          <p:cNvPr id="34" name="TextBox 33"/>
+          <p:cNvSpPr txBox="1"/>
+          <p:nvPr/>
+        </p:nvSpPr>
+        <p:spPr>
+          <a:xfrm>
+            <a:off x="8629650" y="3152775"/>
+            <a:ext cx="676275" cy="190500"/>
           </a:xfrm>
           <a:prstGeom prst="rect">
             <a:avLst/>
@@ -17762,14 +17868,14 @@
       </p:sp>
       <p:sp>
         <p:nvSpPr>
-          <p:cNvPr id="33" name="Rounded Rectangle 32"/>
+          <p:cNvPr id="35" name="Rounded Rectangle 34"/>
           <p:cNvSpPr/>
           <p:nvPr/>
         </p:nvSpPr>
         <p:spPr>
           <a:xfrm>
-            <a:off x="9153525" y="3009900"/>
-            <a:ext cx="723900" cy="419100"/>
+            <a:off x="9353550" y="3009900"/>
+            <a:ext cx="676275" cy="419100"/>
           </a:xfrm>
           <a:prstGeom prst="roundRect">
             <a:avLst>
@@ -17810,14 +17916,14 @@
       </p:sp>
       <p:sp>
         <p:nvSpPr>
-          <p:cNvPr id="34" name="TextBox 33"/>
-          <p:cNvSpPr txBox="1"/>
-          <p:nvPr/>
-        </p:nvSpPr>
-        <p:spPr>
-          <a:xfrm>
-            <a:off x="9153525" y="3152775"/>
-            <a:ext cx="723900" cy="190500"/>
+          <p:cNvPr id="36" name="TextBox 35"/>
+          <p:cNvSpPr txBox="1"/>
+          <p:nvPr/>
+        </p:nvSpPr>
+        <p:spPr>
+          <a:xfrm>
+            <a:off x="9353550" y="3152775"/>
+            <a:ext cx="676275" cy="190500"/>
           </a:xfrm>
           <a:prstGeom prst="rect">
             <a:avLst/>
@@ -17845,14 +17951,14 @@
       </p:sp>
       <p:sp>
         <p:nvSpPr>
-          <p:cNvPr id="35" name="Rounded Rectangle 34"/>
+          <p:cNvPr id="37" name="Rounded Rectangle 36"/>
           <p:cNvSpPr/>
           <p:nvPr/>
         </p:nvSpPr>
         <p:spPr>
           <a:xfrm>
-            <a:off x="9925050" y="3009900"/>
-            <a:ext cx="723900" cy="419100"/>
+            <a:off x="10077450" y="3009900"/>
+            <a:ext cx="676275" cy="419100"/>
           </a:xfrm>
           <a:prstGeom prst="roundRect">
             <a:avLst>
@@ -17893,14 +17999,14 @@
       </p:sp>
       <p:sp>
         <p:nvSpPr>
-          <p:cNvPr id="36" name="TextBox 35"/>
-          <p:cNvSpPr txBox="1"/>
-          <p:nvPr/>
-        </p:nvSpPr>
-        <p:spPr>
-          <a:xfrm>
-            <a:off x="9925050" y="3152775"/>
-            <a:ext cx="723900" cy="190500"/>
+          <p:cNvPr id="38" name="TextBox 37"/>
+          <p:cNvSpPr txBox="1"/>
+          <p:nvPr/>
+        </p:nvSpPr>
+        <p:spPr>
+          <a:xfrm>
+            <a:off x="10077450" y="3152775"/>
+            <a:ext cx="676275" cy="190500"/>
           </a:xfrm>
           <a:prstGeom prst="rect">
             <a:avLst/>
@@ -17928,14 +18034,14 @@
       </p:sp>
       <p:sp>
         <p:nvSpPr>
-          <p:cNvPr id="37" name="Rounded Rectangle 36"/>
+          <p:cNvPr id="39" name="Rounded Rectangle 38"/>
           <p:cNvSpPr/>
           <p:nvPr/>
         </p:nvSpPr>
         <p:spPr>
           <a:xfrm>
-            <a:off x="10696575" y="3009900"/>
-            <a:ext cx="723900" cy="419100"/>
+            <a:off x="10801350" y="3009900"/>
+            <a:ext cx="676275" cy="419100"/>
           </a:xfrm>
           <a:prstGeom prst="roundRect">
             <a:avLst>
@@ -17976,14 +18082,14 @@
       </p:sp>
       <p:sp>
         <p:nvSpPr>
-          <p:cNvPr id="38" name="TextBox 37"/>
-          <p:cNvSpPr txBox="1"/>
-          <p:nvPr/>
-        </p:nvSpPr>
-        <p:spPr>
-          <a:xfrm>
-            <a:off x="10696575" y="3152775"/>
-            <a:ext cx="723900" cy="190500"/>
+          <p:cNvPr id="40" name="TextBox 39"/>
+          <p:cNvSpPr txBox="1"/>
+          <p:nvPr/>
+        </p:nvSpPr>
+        <p:spPr>
+          <a:xfrm>
+            <a:off x="10801350" y="3152775"/>
+            <a:ext cx="676275" cy="190500"/>
           </a:xfrm>
           <a:prstGeom prst="rect">
             <a:avLst/>
@@ -18011,7 +18117,7 @@
       </p:sp>
       <p:sp>
         <p:nvSpPr>
-          <p:cNvPr id="39" name="TextBox 38"/>
+          <p:cNvPr id="41" name="TextBox 40"/>
           <p:cNvSpPr txBox="1"/>
           <p:nvPr/>
         </p:nvSpPr>
@@ -18045,7 +18151,7 @@
       </p:sp>
       <p:sp>
         <p:nvSpPr>
-          <p:cNvPr id="40" name="Rectangle 39"/>
+          <p:cNvPr id="42" name="Rectangle 41"/>
           <p:cNvSpPr/>
           <p:nvPr/>
         </p:nvSpPr>
@@ -18089,7 +18195,7 @@
       </p:sp>
       <p:sp>
         <p:nvSpPr>
-          <p:cNvPr id="41" name="Chevron 40"/>
+          <p:cNvPr id="43" name="Chevron 42"/>
           <p:cNvSpPr/>
           <p:nvPr/>
         </p:nvSpPr>
@@ -18133,7 +18239,7 @@
       </p:sp>
       <p:sp>
         <p:nvSpPr>
-          <p:cNvPr id="42" name="TextBox 41"/>
+          <p:cNvPr id="44" name="TextBox 43"/>
           <p:cNvSpPr txBox="1"/>
           <p:nvPr/>
         </p:nvSpPr>
@@ -18167,14 +18273,14 @@
       </p:sp>
       <p:sp>
         <p:nvSpPr>
-          <p:cNvPr id="43" name="Rounded Rectangle 42"/>
+          <p:cNvPr id="45" name="Rounded Rectangle 44"/>
           <p:cNvSpPr/>
           <p:nvPr/>
         </p:nvSpPr>
         <p:spPr>
           <a:xfrm>
             <a:off x="666750" y="4114800"/>
-            <a:ext cx="723900" cy="419100"/>
+            <a:ext cx="676275" cy="419100"/>
           </a:xfrm>
           <a:prstGeom prst="roundRect">
             <a:avLst>
@@ -18213,14 +18319,14 @@
       </p:sp>
       <p:sp>
         <p:nvSpPr>
-          <p:cNvPr id="44" name="TextBox 43"/>
+          <p:cNvPr id="46" name="TextBox 45"/>
           <p:cNvSpPr txBox="1"/>
           <p:nvPr/>
         </p:nvSpPr>
         <p:spPr>
           <a:xfrm>
             <a:off x="666750" y="4257675"/>
-            <a:ext cx="723900" cy="190500"/>
+            <a:ext cx="676275" cy="190500"/>
           </a:xfrm>
           <a:prstGeom prst="rect">
             <a:avLst/>
@@ -18248,14 +18354,14 @@
       </p:sp>
       <p:sp>
         <p:nvSpPr>
-          <p:cNvPr id="45" name="Rounded Rectangle 44"/>
+          <p:cNvPr id="47" name="Rounded Rectangle 46"/>
           <p:cNvSpPr/>
           <p:nvPr/>
         </p:nvSpPr>
         <p:spPr>
           <a:xfrm>
-            <a:off x="1438275" y="4114800"/>
-            <a:ext cx="723900" cy="419100"/>
+            <a:off x="1390650" y="4114800"/>
+            <a:ext cx="676275" cy="419100"/>
           </a:xfrm>
           <a:prstGeom prst="roundRect">
             <a:avLst>
@@ -18294,14 +18400,14 @@
       </p:sp>
       <p:sp>
         <p:nvSpPr>
-          <p:cNvPr id="46" name="TextBox 45"/>
-          <p:cNvSpPr txBox="1"/>
-          <p:nvPr/>
-        </p:nvSpPr>
-        <p:spPr>
-          <a:xfrm>
-            <a:off x="1438275" y="4257675"/>
-            <a:ext cx="723900" cy="190500"/>
+          <p:cNvPr id="48" name="TextBox 47"/>
+          <p:cNvSpPr txBox="1"/>
+          <p:nvPr/>
+        </p:nvSpPr>
+        <p:spPr>
+          <a:xfrm>
+            <a:off x="1390650" y="4257675"/>
+            <a:ext cx="676275" cy="190500"/>
           </a:xfrm>
           <a:prstGeom prst="rect">
             <a:avLst/>
@@ -18322,21 +18428,21 @@
                 </a:solidFill>
                 <a:latin typeface="Helvetica Neue"/>
               </a:rPr>
-              <a:t>python</a:t>
-            </a:r>
-          </a:p>
-        </p:txBody>
-      </p:sp>
-      <p:sp>
-        <p:nvSpPr>
-          <p:cNvPr id="47" name="Rounded Rectangle 46"/>
+              <a:t>export</a:t>
+            </a:r>
+          </a:p>
+        </p:txBody>
+      </p:sp>
+      <p:sp>
+        <p:nvSpPr>
+          <p:cNvPr id="49" name="Rounded Rectangle 48"/>
           <p:cNvSpPr/>
           <p:nvPr/>
         </p:nvSpPr>
         <p:spPr>
           <a:xfrm>
-            <a:off x="2209800" y="4114800"/>
-            <a:ext cx="723900" cy="419100"/>
+            <a:off x="2114550" y="4114800"/>
+            <a:ext cx="676275" cy="419100"/>
           </a:xfrm>
           <a:prstGeom prst="roundRect">
             <a:avLst>
@@ -18375,14 +18481,14 @@
       </p:sp>
       <p:sp>
         <p:nvSpPr>
-          <p:cNvPr id="48" name="TextBox 47"/>
-          <p:cNvSpPr txBox="1"/>
-          <p:nvPr/>
-        </p:nvSpPr>
-        <p:spPr>
-          <a:xfrm>
-            <a:off x="2209800" y="4257675"/>
-            <a:ext cx="723900" cy="190500"/>
+          <p:cNvPr id="50" name="TextBox 49"/>
+          <p:cNvSpPr txBox="1"/>
+          <p:nvPr/>
+        </p:nvSpPr>
+        <p:spPr>
+          <a:xfrm>
+            <a:off x="2114550" y="4257675"/>
+            <a:ext cx="676275" cy="190500"/>
           </a:xfrm>
           <a:prstGeom prst="rect">
             <a:avLst/>
@@ -18403,21 +18509,21 @@
                 </a:solidFill>
                 <a:latin typeface="Helvetica Neue"/>
               </a:rPr>
-              <a:t>lint</a:t>
-            </a:r>
-          </a:p>
-        </p:txBody>
-      </p:sp>
-      <p:sp>
-        <p:nvSpPr>
-          <p:cNvPr id="49" name="Rounded Rectangle 48"/>
+              <a:t>python</a:t>
+            </a:r>
+          </a:p>
+        </p:txBody>
+      </p:sp>
+      <p:sp>
+        <p:nvSpPr>
+          <p:cNvPr id="51" name="Rounded Rectangle 50"/>
           <p:cNvSpPr/>
           <p:nvPr/>
         </p:nvSpPr>
         <p:spPr>
           <a:xfrm>
-            <a:off x="2981325" y="4114800"/>
-            <a:ext cx="723900" cy="419100"/>
+            <a:off x="2838450" y="4114800"/>
+            <a:ext cx="676275" cy="419100"/>
           </a:xfrm>
           <a:prstGeom prst="roundRect">
             <a:avLst>
@@ -18456,14 +18562,14 @@
       </p:sp>
       <p:sp>
         <p:nvSpPr>
-          <p:cNvPr id="50" name="TextBox 49"/>
-          <p:cNvSpPr txBox="1"/>
-          <p:nvPr/>
-        </p:nvSpPr>
-        <p:spPr>
-          <a:xfrm>
-            <a:off x="2981325" y="4257675"/>
-            <a:ext cx="723900" cy="190500"/>
+          <p:cNvPr id="52" name="TextBox 51"/>
+          <p:cNvSpPr txBox="1"/>
+          <p:nvPr/>
+        </p:nvSpPr>
+        <p:spPr>
+          <a:xfrm>
+            <a:off x="2838450" y="4257675"/>
+            <a:ext cx="676275" cy="190500"/>
           </a:xfrm>
           <a:prstGeom prst="rect">
             <a:avLst/>
@@ -18484,21 +18590,21 @@
                 </a:solidFill>
                 <a:latin typeface="Helvetica Neue"/>
               </a:rPr>
-              <a:t>format</a:t>
-            </a:r>
-          </a:p>
-        </p:txBody>
-      </p:sp>
-      <p:sp>
-        <p:nvSpPr>
-          <p:cNvPr id="51" name="Rounded Rectangle 50"/>
+              <a:t>lint</a:t>
+            </a:r>
+          </a:p>
+        </p:txBody>
+      </p:sp>
+      <p:sp>
+        <p:nvSpPr>
+          <p:cNvPr id="53" name="Rounded Rectangle 52"/>
           <p:cNvSpPr/>
           <p:nvPr/>
         </p:nvSpPr>
         <p:spPr>
           <a:xfrm>
-            <a:off x="3752850" y="4114800"/>
-            <a:ext cx="723900" cy="419100"/>
+            <a:off x="3562350" y="4114800"/>
+            <a:ext cx="676275" cy="419100"/>
           </a:xfrm>
           <a:prstGeom prst="roundRect">
             <a:avLst>
@@ -18537,14 +18643,14 @@
       </p:sp>
       <p:sp>
         <p:nvSpPr>
-          <p:cNvPr id="52" name="TextBox 51"/>
-          <p:cNvSpPr txBox="1"/>
-          <p:nvPr/>
-        </p:nvSpPr>
-        <p:spPr>
-          <a:xfrm>
-            <a:off x="3752850" y="4257675"/>
-            <a:ext cx="723900" cy="190500"/>
+          <p:cNvPr id="54" name="TextBox 53"/>
+          <p:cNvSpPr txBox="1"/>
+          <p:nvPr/>
+        </p:nvSpPr>
+        <p:spPr>
+          <a:xfrm>
+            <a:off x="3562350" y="4257675"/>
+            <a:ext cx="676275" cy="190500"/>
           </a:xfrm>
           <a:prstGeom prst="rect">
             <a:avLst/>
@@ -18565,21 +18671,21 @@
                 </a:solidFill>
                 <a:latin typeface="Helvetica Neue"/>
               </a:rPr>
-              <a:t>openspec</a:t>
-            </a:r>
-          </a:p>
-        </p:txBody>
-      </p:sp>
-      <p:sp>
-        <p:nvSpPr>
-          <p:cNvPr id="53" name="Rounded Rectangle 52"/>
+              <a:t>format</a:t>
+            </a:r>
+          </a:p>
+        </p:txBody>
+      </p:sp>
+      <p:sp>
+        <p:nvSpPr>
+          <p:cNvPr id="55" name="Rounded Rectangle 54"/>
           <p:cNvSpPr/>
           <p:nvPr/>
         </p:nvSpPr>
         <p:spPr>
           <a:xfrm>
-            <a:off x="4524375" y="4114800"/>
-            <a:ext cx="723900" cy="419100"/>
+            <a:off x="4286250" y="4114800"/>
+            <a:ext cx="676275" cy="419100"/>
           </a:xfrm>
           <a:prstGeom prst="roundRect">
             <a:avLst>
@@ -18618,14 +18724,14 @@
       </p:sp>
       <p:sp>
         <p:nvSpPr>
-          <p:cNvPr id="54" name="TextBox 53"/>
-          <p:cNvSpPr txBox="1"/>
-          <p:nvPr/>
-        </p:nvSpPr>
-        <p:spPr>
-          <a:xfrm>
-            <a:off x="4524375" y="4257675"/>
-            <a:ext cx="723900" cy="190500"/>
+          <p:cNvPr id="56" name="TextBox 55"/>
+          <p:cNvSpPr txBox="1"/>
+          <p:nvPr/>
+        </p:nvSpPr>
+        <p:spPr>
+          <a:xfrm>
+            <a:off x="4286250" y="4257675"/>
+            <a:ext cx="676275" cy="190500"/>
           </a:xfrm>
           <a:prstGeom prst="rect">
             <a:avLst/>
@@ -18646,21 +18752,21 @@
                 </a:solidFill>
                 <a:latin typeface="Helvetica Neue"/>
               </a:rPr>
-              <a:t>doc-check</a:t>
-            </a:r>
-          </a:p>
-        </p:txBody>
-      </p:sp>
-      <p:sp>
-        <p:nvSpPr>
-          <p:cNvPr id="55" name="Rounded Rectangle 54"/>
+              <a:t>openspec</a:t>
+            </a:r>
+          </a:p>
+        </p:txBody>
+      </p:sp>
+      <p:sp>
+        <p:nvSpPr>
+          <p:cNvPr id="57" name="Rounded Rectangle 56"/>
           <p:cNvSpPr/>
           <p:nvPr/>
         </p:nvSpPr>
         <p:spPr>
           <a:xfrm>
-            <a:off x="5295900" y="4114800"/>
-            <a:ext cx="723900" cy="419100"/>
+            <a:off x="5010150" y="4114800"/>
+            <a:ext cx="676275" cy="419100"/>
           </a:xfrm>
           <a:prstGeom prst="roundRect">
             <a:avLst>
@@ -18668,7 +18774,7 @@
             </a:avLst>
           </a:prstGeom>
           <a:solidFill>
-            <a:srgbClr val="7BC6A4"/>
+            <a:srgbClr val="23282F"/>
           </a:solidFill>
           <a:ln>
             <a:noFill/>
@@ -18699,14 +18805,14 @@
       </p:sp>
       <p:sp>
         <p:nvSpPr>
-          <p:cNvPr id="56" name="TextBox 55"/>
-          <p:cNvSpPr txBox="1"/>
-          <p:nvPr/>
-        </p:nvSpPr>
-        <p:spPr>
-          <a:xfrm>
-            <a:off x="5295900" y="4257675"/>
-            <a:ext cx="723900" cy="190500"/>
+          <p:cNvPr id="58" name="TextBox 57"/>
+          <p:cNvSpPr txBox="1"/>
+          <p:nvPr/>
+        </p:nvSpPr>
+        <p:spPr>
+          <a:xfrm>
+            <a:off x="5010150" y="4257675"/>
+            <a:ext cx="676275" cy="190500"/>
           </a:xfrm>
           <a:prstGeom prst="rect">
             <a:avLst/>
@@ -18723,25 +18829,25 @@
             <a:r>
               <a:rPr sz="800" b="1" i="0">
                 <a:solidFill>
-                  <a:srgbClr val="101317"/>
-                </a:solidFill>
-                <a:latin typeface="Helvetica Neue"/>
-              </a:rPr>
-              <a:t>driver</a:t>
-            </a:r>
-          </a:p>
-        </p:txBody>
-      </p:sp>
-      <p:sp>
-        <p:nvSpPr>
-          <p:cNvPr id="57" name="Rounded Rectangle 56"/>
+                  <a:srgbClr val="AAB3BC"/>
+                </a:solidFill>
+                <a:latin typeface="Helvetica Neue"/>
+              </a:rPr>
+              <a:t>doc-check</a:t>
+            </a:r>
+          </a:p>
+        </p:txBody>
+      </p:sp>
+      <p:sp>
+        <p:nvSpPr>
+          <p:cNvPr id="59" name="Rounded Rectangle 58"/>
           <p:cNvSpPr/>
           <p:nvPr/>
         </p:nvSpPr>
         <p:spPr>
           <a:xfrm>
-            <a:off x="6067425" y="4114800"/>
-            <a:ext cx="723900" cy="419100"/>
+            <a:off x="5734050" y="4114800"/>
+            <a:ext cx="676275" cy="419100"/>
           </a:xfrm>
           <a:prstGeom prst="roundRect">
             <a:avLst>
@@ -18780,14 +18886,14 @@
       </p:sp>
       <p:sp>
         <p:nvSpPr>
-          <p:cNvPr id="58" name="TextBox 57"/>
-          <p:cNvSpPr txBox="1"/>
-          <p:nvPr/>
-        </p:nvSpPr>
-        <p:spPr>
-          <a:xfrm>
-            <a:off x="6067425" y="4257675"/>
-            <a:ext cx="723900" cy="190500"/>
+          <p:cNvPr id="60" name="TextBox 59"/>
+          <p:cNvSpPr txBox="1"/>
+          <p:nvPr/>
+        </p:nvSpPr>
+        <p:spPr>
+          <a:xfrm>
+            <a:off x="5734050" y="4257675"/>
+            <a:ext cx="676275" cy="190500"/>
           </a:xfrm>
           <a:prstGeom prst="rect">
             <a:avLst/>
@@ -18808,21 +18914,21 @@
                 </a:solidFill>
                 <a:latin typeface="Helvetica Neue"/>
               </a:rPr>
-              <a:t>skills</a:t>
-            </a:r>
-          </a:p>
-        </p:txBody>
-      </p:sp>
-      <p:sp>
-        <p:nvSpPr>
-          <p:cNvPr id="59" name="Rounded Rectangle 58"/>
+              <a:t>driver</a:t>
+            </a:r>
+          </a:p>
+        </p:txBody>
+      </p:sp>
+      <p:sp>
+        <p:nvSpPr>
+          <p:cNvPr id="61" name="Rounded Rectangle 60"/>
           <p:cNvSpPr/>
           <p:nvPr/>
         </p:nvSpPr>
         <p:spPr>
           <a:xfrm>
-            <a:off x="6838950" y="4114800"/>
-            <a:ext cx="723900" cy="419100"/>
+            <a:off x="6457950" y="4114800"/>
+            <a:ext cx="676275" cy="419100"/>
           </a:xfrm>
           <a:prstGeom prst="roundRect">
             <a:avLst>
@@ -18861,14 +18967,14 @@
       </p:sp>
       <p:sp>
         <p:nvSpPr>
-          <p:cNvPr id="60" name="TextBox 59"/>
-          <p:cNvSpPr txBox="1"/>
-          <p:nvPr/>
-        </p:nvSpPr>
-        <p:spPr>
-          <a:xfrm>
-            <a:off x="6838950" y="4257675"/>
-            <a:ext cx="723900" cy="190500"/>
+          <p:cNvPr id="62" name="TextBox 61"/>
+          <p:cNvSpPr txBox="1"/>
+          <p:nvPr/>
+        </p:nvSpPr>
+        <p:spPr>
+          <a:xfrm>
+            <a:off x="6457950" y="4257675"/>
+            <a:ext cx="676275" cy="190500"/>
           </a:xfrm>
           <a:prstGeom prst="rect">
             <a:avLst/>
@@ -18889,21 +18995,21 @@
                 </a:solidFill>
                 <a:latin typeface="Helvetica Neue"/>
               </a:rPr>
-              <a:t>e2e</a:t>
-            </a:r>
-          </a:p>
-        </p:txBody>
-      </p:sp>
-      <p:sp>
-        <p:nvSpPr>
-          <p:cNvPr id="61" name="Rounded Rectangle 60"/>
+              <a:t>skills</a:t>
+            </a:r>
+          </a:p>
+        </p:txBody>
+      </p:sp>
+      <p:sp>
+        <p:nvSpPr>
+          <p:cNvPr id="63" name="Rounded Rectangle 62"/>
           <p:cNvSpPr/>
           <p:nvPr/>
         </p:nvSpPr>
         <p:spPr>
           <a:xfrm>
-            <a:off x="7610475" y="4114800"/>
-            <a:ext cx="723900" cy="419100"/>
+            <a:off x="7181850" y="4114800"/>
+            <a:ext cx="676275" cy="419100"/>
           </a:xfrm>
           <a:prstGeom prst="roundRect">
             <a:avLst>
@@ -18942,14 +19048,14 @@
       </p:sp>
       <p:sp>
         <p:nvSpPr>
-          <p:cNvPr id="62" name="TextBox 61"/>
-          <p:cNvSpPr txBox="1"/>
-          <p:nvPr/>
-        </p:nvSpPr>
-        <p:spPr>
-          <a:xfrm>
-            <a:off x="7610475" y="4257675"/>
-            <a:ext cx="723900" cy="190500"/>
+          <p:cNvPr id="64" name="TextBox 63"/>
+          <p:cNvSpPr txBox="1"/>
+          <p:nvPr/>
+        </p:nvSpPr>
+        <p:spPr>
+          <a:xfrm>
+            <a:off x="7181850" y="4257675"/>
+            <a:ext cx="676275" cy="190500"/>
           </a:xfrm>
           <a:prstGeom prst="rect">
             <a:avLst/>
@@ -18970,21 +19076,21 @@
                 </a:solidFill>
                 <a:latin typeface="Helvetica Neue"/>
               </a:rPr>
-              <a:t>wheel</a:t>
-            </a:r>
-          </a:p>
-        </p:txBody>
-      </p:sp>
-      <p:sp>
-        <p:nvSpPr>
-          <p:cNvPr id="63" name="Rounded Rectangle 62"/>
+              <a:t>e2e</a:t>
+            </a:r>
+          </a:p>
+        </p:txBody>
+      </p:sp>
+      <p:sp>
+        <p:nvSpPr>
+          <p:cNvPr id="65" name="Rounded Rectangle 64"/>
           <p:cNvSpPr/>
           <p:nvPr/>
         </p:nvSpPr>
         <p:spPr>
           <a:xfrm>
-            <a:off x="8382000" y="4114800"/>
-            <a:ext cx="723900" cy="419100"/>
+            <a:off x="7905750" y="4114800"/>
+            <a:ext cx="676275" cy="419100"/>
           </a:xfrm>
           <a:prstGeom prst="roundRect">
             <a:avLst>
@@ -19023,14 +19129,14 @@
       </p:sp>
       <p:sp>
         <p:nvSpPr>
-          <p:cNvPr id="64" name="TextBox 63"/>
-          <p:cNvSpPr txBox="1"/>
-          <p:nvPr/>
-        </p:nvSpPr>
-        <p:spPr>
-          <a:xfrm>
-            <a:off x="8382000" y="4257675"/>
-            <a:ext cx="723900" cy="190500"/>
+          <p:cNvPr id="66" name="TextBox 65"/>
+          <p:cNvSpPr txBox="1"/>
+          <p:nvPr/>
+        </p:nvSpPr>
+        <p:spPr>
+          <a:xfrm>
+            <a:off x="7905750" y="4257675"/>
+            <a:ext cx="676275" cy="190500"/>
           </a:xfrm>
           <a:prstGeom prst="rect">
             <a:avLst/>
@@ -19051,21 +19157,21 @@
                 </a:solidFill>
                 <a:latin typeface="Helvetica Neue"/>
               </a:rPr>
-              <a:t>install</a:t>
-            </a:r>
-          </a:p>
-        </p:txBody>
-      </p:sp>
-      <p:sp>
-        <p:nvSpPr>
-          <p:cNvPr id="65" name="Rounded Rectangle 64"/>
+              <a:t>wheel</a:t>
+            </a:r>
+          </a:p>
+        </p:txBody>
+      </p:sp>
+      <p:sp>
+        <p:nvSpPr>
+          <p:cNvPr id="67" name="Rounded Rectangle 66"/>
           <p:cNvSpPr/>
           <p:nvPr/>
         </p:nvSpPr>
         <p:spPr>
           <a:xfrm>
-            <a:off x="9153525" y="4114800"/>
-            <a:ext cx="723900" cy="419100"/>
+            <a:off x="8629650" y="4114800"/>
+            <a:ext cx="676275" cy="419100"/>
           </a:xfrm>
           <a:prstGeom prst="roundRect">
             <a:avLst>
@@ -19104,14 +19210,14 @@
       </p:sp>
       <p:sp>
         <p:nvSpPr>
-          <p:cNvPr id="66" name="TextBox 65"/>
-          <p:cNvSpPr txBox="1"/>
-          <p:nvPr/>
-        </p:nvSpPr>
-        <p:spPr>
-          <a:xfrm>
-            <a:off x="9153525" y="4257675"/>
-            <a:ext cx="723900" cy="190500"/>
+          <p:cNvPr id="68" name="TextBox 67"/>
+          <p:cNvSpPr txBox="1"/>
+          <p:nvPr/>
+        </p:nvSpPr>
+        <p:spPr>
+          <a:xfrm>
+            <a:off x="8629650" y="4257675"/>
+            <a:ext cx="676275" cy="190500"/>
           </a:xfrm>
           <a:prstGeom prst="rect">
             <a:avLst/>
@@ -19132,21 +19238,21 @@
                 </a:solidFill>
                 <a:latin typeface="Helvetica Neue"/>
               </a:rPr>
-              <a:t>proj-e2e</a:t>
-            </a:r>
-          </a:p>
-        </p:txBody>
-      </p:sp>
-      <p:sp>
-        <p:nvSpPr>
-          <p:cNvPr id="67" name="Rounded Rectangle 66"/>
+              <a:t>install</a:t>
+            </a:r>
+          </a:p>
+        </p:txBody>
+      </p:sp>
+      <p:sp>
+        <p:nvSpPr>
+          <p:cNvPr id="69" name="Rounded Rectangle 68"/>
           <p:cNvSpPr/>
           <p:nvPr/>
         </p:nvSpPr>
         <p:spPr>
           <a:xfrm>
-            <a:off x="9925050" y="4114800"/>
-            <a:ext cx="723900" cy="419100"/>
+            <a:off x="9353550" y="4114800"/>
+            <a:ext cx="676275" cy="419100"/>
           </a:xfrm>
           <a:prstGeom prst="roundRect">
             <a:avLst>
@@ -19185,14 +19291,14 @@
       </p:sp>
       <p:sp>
         <p:nvSpPr>
-          <p:cNvPr id="68" name="TextBox 67"/>
-          <p:cNvSpPr txBox="1"/>
-          <p:nvPr/>
-        </p:nvSpPr>
-        <p:spPr>
-          <a:xfrm>
-            <a:off x="9925050" y="4257675"/>
-            <a:ext cx="723900" cy="190500"/>
+          <p:cNvPr id="70" name="TextBox 69"/>
+          <p:cNvSpPr txBox="1"/>
+          <p:nvPr/>
+        </p:nvSpPr>
+        <p:spPr>
+          <a:xfrm>
+            <a:off x="9353550" y="4257675"/>
+            <a:ext cx="676275" cy="190500"/>
           </a:xfrm>
           <a:prstGeom prst="rect">
             <a:avLst/>
@@ -19213,21 +19319,21 @@
                 </a:solidFill>
                 <a:latin typeface="Helvetica Neue"/>
               </a:rPr>
-              <a:t>samples</a:t>
-            </a:r>
-          </a:p>
-        </p:txBody>
-      </p:sp>
-      <p:sp>
-        <p:nvSpPr>
-          <p:cNvPr id="69" name="Rounded Rectangle 68"/>
+              <a:t>proj-e2e</a:t>
+            </a:r>
+          </a:p>
+        </p:txBody>
+      </p:sp>
+      <p:sp>
+        <p:nvSpPr>
+          <p:cNvPr id="71" name="Rounded Rectangle 70"/>
           <p:cNvSpPr/>
           <p:nvPr/>
         </p:nvSpPr>
         <p:spPr>
           <a:xfrm>
-            <a:off x="10696575" y="4114800"/>
-            <a:ext cx="723900" cy="419100"/>
+            <a:off x="10077450" y="4114800"/>
+            <a:ext cx="676275" cy="419100"/>
           </a:xfrm>
           <a:prstGeom prst="roundRect">
             <a:avLst>
@@ -19266,14 +19372,14 @@
       </p:sp>
       <p:sp>
         <p:nvSpPr>
-          <p:cNvPr id="70" name="TextBox 69"/>
-          <p:cNvSpPr txBox="1"/>
-          <p:nvPr/>
-        </p:nvSpPr>
-        <p:spPr>
-          <a:xfrm>
-            <a:off x="10696575" y="4257675"/>
-            <a:ext cx="723900" cy="190500"/>
+          <p:cNvPr id="72" name="TextBox 71"/>
+          <p:cNvSpPr txBox="1"/>
+          <p:nvPr/>
+        </p:nvSpPr>
+        <p:spPr>
+          <a:xfrm>
+            <a:off x="10077450" y="4257675"/>
+            <a:ext cx="676275" cy="190500"/>
           </a:xfrm>
           <a:prstGeom prst="rect">
             <a:avLst/>
@@ -19294,55 +19400,21 @@
                 </a:solidFill>
                 <a:latin typeface="Helvetica Neue"/>
               </a:rPr>
-              <a:t>receipt</a:t>
-            </a:r>
-          </a:p>
-        </p:txBody>
-      </p:sp>
-      <p:sp>
-        <p:nvSpPr>
-          <p:cNvPr id="71" name="TextBox 70"/>
-          <p:cNvSpPr txBox="1"/>
-          <p:nvPr/>
-        </p:nvSpPr>
-        <p:spPr>
-          <a:xfrm>
-            <a:off x="666750" y="4610100"/>
-            <a:ext cx="8572500" cy="190500"/>
-          </a:xfrm>
-          <a:prstGeom prst="rect">
-            <a:avLst/>
-          </a:prstGeom>
-          <a:noFill/>
-        </p:spPr>
-        <p:txBody>
-          <a:bodyPr wrap="square" anchor="t" lIns="0" rIns="0" tIns="0" bIns="0">
-            <a:spAutoFit/>
-          </a:bodyPr>
-          <a:lstStyle/>
-          <a:p>
-            <a:r>
-              <a:rPr sz="1300" b="1" i="0">
-                <a:solidFill>
-                  <a:srgbClr val="76B900"/>
-                </a:solidFill>
-                <a:latin typeface="Helvetica Neue"/>
-              </a:rPr>
-              <a:t>SECOND RUN — the first six gates are not rerun; only driver-review onward executes</a:t>
-            </a:r>
-          </a:p>
-        </p:txBody>
-      </p:sp>
-      <p:sp>
-        <p:nvSpPr>
-          <p:cNvPr id="72" name="Rounded Rectangle 71"/>
+              <a:t>samples</a:t>
+            </a:r>
+          </a:p>
+        </p:txBody>
+      </p:sp>
+      <p:sp>
+        <p:nvSpPr>
+          <p:cNvPr id="73" name="Rounded Rectangle 72"/>
           <p:cNvSpPr/>
           <p:nvPr/>
         </p:nvSpPr>
         <p:spPr>
           <a:xfrm>
-            <a:off x="666750" y="5029200"/>
-            <a:ext cx="10858500" cy="914400"/>
+            <a:off x="10801350" y="4114800"/>
+            <a:ext cx="676275" cy="419100"/>
           </a:xfrm>
           <a:prstGeom prst="roundRect">
             <a:avLst>
@@ -19350,7 +19422,7 @@
             </a:avLst>
           </a:prstGeom>
           <a:solidFill>
-            <a:srgbClr val="1A1F26"/>
+            <a:srgbClr val="7BC6A4"/>
           </a:solidFill>
           <a:ln>
             <a:noFill/>
@@ -19381,14 +19453,14 @@
       </p:sp>
       <p:sp>
         <p:nvSpPr>
-          <p:cNvPr id="73" name="TextBox 72"/>
-          <p:cNvSpPr txBox="1"/>
-          <p:nvPr/>
-        </p:nvSpPr>
-        <p:spPr>
-          <a:xfrm>
-            <a:off x="876300" y="5200650"/>
-            <a:ext cx="10439400" cy="609600"/>
+          <p:cNvPr id="74" name="TextBox 73"/>
+          <p:cNvSpPr txBox="1"/>
+          <p:nvPr/>
+        </p:nvSpPr>
+        <p:spPr>
+          <a:xfrm>
+            <a:off x="10801350" y="4257675"/>
+            <a:ext cx="676275" cy="190500"/>
           </a:xfrm>
           <a:prstGeom prst="rect">
             <a:avLst/>
@@ -19401,50 +19473,29 @@
           </a:bodyPr>
           <a:lstStyle/>
           <a:p>
-            <a:r>
-              <a:rPr sz="1300" b="0" i="0">
-                <a:solidFill>
-                  <a:srgbClr val="EEF1F3"/>
-                </a:solidFill>
-                <a:latin typeface="Courier New"/>
-              </a:rPr>
-              <a:t>python-check: content-hash per test module — always safe to trust a resume</a:t>
-            </a:r>
-          </a:p>
-          <a:p>
-            <a:r>
-              <a:rPr sz="1300" b="0" i="0">
-                <a:solidFill>
-                  <a:srgbClr val="EEF1F3"/>
-                </a:solidFill>
-                <a:latin typeface="Courier New"/>
-              </a:rPr>
-              <a:t>release-check: gate-name list only, no content fingerprint — reset explicitly</a:t>
-            </a:r>
-          </a:p>
-          <a:p>
-            <a:r>
-              <a:rPr sz="1300" b="0" i="0">
-                <a:solidFill>
-                  <a:srgbClr val="EEF1F3"/>
-                </a:solidFill>
-                <a:latin typeface="Courier New"/>
-              </a:rPr>
-              <a:t>                before re-validating a checkout against a different commit</a:t>
-            </a:r>
-          </a:p>
-        </p:txBody>
-      </p:sp>
-      <p:sp>
-        <p:nvSpPr>
-          <p:cNvPr id="74" name="TextBox 73"/>
-          <p:cNvSpPr txBox="1"/>
-          <p:nvPr/>
-        </p:nvSpPr>
-        <p:spPr>
-          <a:xfrm>
-            <a:off x="666750" y="6648450"/>
-            <a:ext cx="1428750" cy="152400"/>
+            <a:pPr algn="ctr"/>
+            <a:r>
+              <a:rPr sz="800" b="1" i="0">
+                <a:solidFill>
+                  <a:srgbClr val="101317"/>
+                </a:solidFill>
+                <a:latin typeface="Helvetica Neue"/>
+              </a:rPr>
+              <a:t>receipt</a:t>
+            </a:r>
+          </a:p>
+        </p:txBody>
+      </p:sp>
+      <p:sp>
+        <p:nvSpPr>
+          <p:cNvPr id="75" name="TextBox 74"/>
+          <p:cNvSpPr txBox="1"/>
+          <p:nvPr/>
+        </p:nvSpPr>
+        <p:spPr>
+          <a:xfrm>
+            <a:off x="666750" y="4610100"/>
+            <a:ext cx="8572500" cy="190500"/>
           </a:xfrm>
           <a:prstGeom prst="rect">
             <a:avLst/>
@@ -19458,33 +19509,35 @@
           <a:lstStyle/>
           <a:p>
             <a:r>
-              <a:rPr sz="1100" b="1" i="0">
-                <a:solidFill>
-                  <a:srgbClr val="65707C"/>
-                </a:solidFill>
-                <a:latin typeface="Helvetica Neue"/>
-              </a:rPr>
-              <a:t>LITERATE-AI</a:t>
-            </a:r>
-          </a:p>
-        </p:txBody>
-      </p:sp>
-      <p:sp>
-        <p:nvSpPr>
-          <p:cNvPr id="75" name="Rectangle 74"/>
+              <a:rPr sz="1300" b="1" i="0">
+                <a:solidFill>
+                  <a:srgbClr val="76B900"/>
+                </a:solidFill>
+                <a:latin typeface="Helvetica Neue"/>
+              </a:rPr>
+              <a:t>SECOND RUN — the first seven gates are not rerun; only driver-review onward executes</a:t>
+            </a:r>
+          </a:p>
+        </p:txBody>
+      </p:sp>
+      <p:sp>
+        <p:nvSpPr>
+          <p:cNvPr id="76" name="Rounded Rectangle 75"/>
           <p:cNvSpPr/>
           <p:nvPr/>
         </p:nvSpPr>
         <p:spPr>
           <a:xfrm>
-            <a:off x="10287000" y="6705600"/>
-            <a:ext cx="1143000" cy="28575"/>
-          </a:xfrm>
-          <a:prstGeom prst="rect">
-            <a:avLst/>
-          </a:prstGeom>
-          <a:solidFill>
-            <a:srgbClr val="D8DEE3"/>
+            <a:off x="666750" y="5029200"/>
+            <a:ext cx="10858500" cy="914400"/>
+          </a:xfrm>
+          <a:prstGeom prst="roundRect">
+            <a:avLst>
+              <a:gd name="adj" fmla="val 9000"/>
+            </a:avLst>
+          </a:prstGeom>
+          <a:solidFill>
+            <a:srgbClr val="1A1F26"/>
           </a:solidFill>
           <a:ln>
             <a:noFill/>
@@ -19515,7 +19568,141 @@
       </p:sp>
       <p:sp>
         <p:nvSpPr>
-          <p:cNvPr id="76" name="Rectangle 75"/>
+          <p:cNvPr id="77" name="TextBox 76"/>
+          <p:cNvSpPr txBox="1"/>
+          <p:nvPr/>
+        </p:nvSpPr>
+        <p:spPr>
+          <a:xfrm>
+            <a:off x="876300" y="5200650"/>
+            <a:ext cx="10439400" cy="609600"/>
+          </a:xfrm>
+          <a:prstGeom prst="rect">
+            <a:avLst/>
+          </a:prstGeom>
+          <a:noFill/>
+        </p:spPr>
+        <p:txBody>
+          <a:bodyPr wrap="square" anchor="t" lIns="0" rIns="0" tIns="0" bIns="0">
+            <a:spAutoFit/>
+          </a:bodyPr>
+          <a:lstStyle/>
+          <a:p>
+            <a:r>
+              <a:rPr sz="1300" b="0" i="0">
+                <a:solidFill>
+                  <a:srgbClr val="EEF1F3"/>
+                </a:solidFill>
+                <a:latin typeface="Courier New"/>
+              </a:rPr>
+              <a:t>python-check: content-hash per test module — always safe to trust a resume</a:t>
+            </a:r>
+          </a:p>
+          <a:p>
+            <a:r>
+              <a:rPr sz="1300" b="0" i="0">
+                <a:solidFill>
+                  <a:srgbClr val="EEF1F3"/>
+                </a:solidFill>
+                <a:latin typeface="Courier New"/>
+              </a:rPr>
+              <a:t>release-check: gate-name list only, no content fingerprint — reset explicitly</a:t>
+            </a:r>
+          </a:p>
+          <a:p>
+            <a:r>
+              <a:rPr sz="1300" b="0" i="0">
+                <a:solidFill>
+                  <a:srgbClr val="EEF1F3"/>
+                </a:solidFill>
+                <a:latin typeface="Courier New"/>
+              </a:rPr>
+              <a:t>                before re-validating a checkout against a different commit</a:t>
+            </a:r>
+          </a:p>
+        </p:txBody>
+      </p:sp>
+      <p:sp>
+        <p:nvSpPr>
+          <p:cNvPr id="78" name="TextBox 77"/>
+          <p:cNvSpPr txBox="1"/>
+          <p:nvPr/>
+        </p:nvSpPr>
+        <p:spPr>
+          <a:xfrm>
+            <a:off x="666750" y="6648450"/>
+            <a:ext cx="1428750" cy="152400"/>
+          </a:xfrm>
+          <a:prstGeom prst="rect">
+            <a:avLst/>
+          </a:prstGeom>
+          <a:noFill/>
+        </p:spPr>
+        <p:txBody>
+          <a:bodyPr wrap="square" anchor="t" lIns="0" rIns="0" tIns="0" bIns="0">
+            <a:spAutoFit/>
+          </a:bodyPr>
+          <a:lstStyle/>
+          <a:p>
+            <a:r>
+              <a:rPr sz="1100" b="1" i="0">
+                <a:solidFill>
+                  <a:srgbClr val="65707C"/>
+                </a:solidFill>
+                <a:latin typeface="Helvetica Neue"/>
+              </a:rPr>
+              <a:t>LITERATE-AI</a:t>
+            </a:r>
+          </a:p>
+        </p:txBody>
+      </p:sp>
+      <p:sp>
+        <p:nvSpPr>
+          <p:cNvPr id="79" name="Rectangle 78"/>
+          <p:cNvSpPr/>
+          <p:nvPr/>
+        </p:nvSpPr>
+        <p:spPr>
+          <a:xfrm>
+            <a:off x="10287000" y="6705600"/>
+            <a:ext cx="1143000" cy="28575"/>
+          </a:xfrm>
+          <a:prstGeom prst="rect">
+            <a:avLst/>
+          </a:prstGeom>
+          <a:solidFill>
+            <a:srgbClr val="D8DEE3"/>
+          </a:solidFill>
+          <a:ln>
+            <a:noFill/>
+          </a:ln>
+          <a:effectLst/>
+        </p:spPr>
+        <p:style>
+          <a:lnRef idx="1">
+            <a:schemeClr val="accent1"/>
+          </a:lnRef>
+          <a:fillRef idx="3">
+            <a:schemeClr val="accent1"/>
+          </a:fillRef>
+          <a:effectRef idx="2">
+            <a:schemeClr val="accent1"/>
+          </a:effectRef>
+          <a:fontRef idx="minor">
+            <a:schemeClr val="lt1"/>
+          </a:fontRef>
+        </p:style>
+        <p:txBody>
+          <a:bodyPr rtlCol="0" anchor="ctr"/>
+          <a:lstStyle/>
+          <a:p>
+            <a:pPr algn="ctr"/>
+          </a:p>
+        </p:txBody>
+      </p:sp>
+      <p:sp>
+        <p:nvSpPr>
+          <p:cNvPr id="80" name="Rectangle 79"/>
           <p:cNvSpPr/>
           <p:nvPr/>
         </p:nvSpPr>
@@ -25318,7 +25505,7 @@
                 </a:solidFill>
                 <a:latin typeface="Helvetica Neue"/>
               </a:rPr>
-              <a:t>1.1 overlaps exact work and reuses only verified bytes.</a:t>
+              <a:t>1.2 distributes exact work and bounds candidate repair.</a:t>
             </a:r>
           </a:p>
         </p:txBody>
@@ -25352,7 +25539,7 @@
                 </a:solidFill>
                 <a:latin typeface="Helvetica Neue"/>
               </a:rPr>
-              <a:t>Bounded DAG scheduling, cache authority, Debian packages, native acceptance, and worktree placement advance together.</a:t>
+              <a:t>Candidate repair, cross-host action workers, native Mix builds, and forge coordination build on the 1.1 scheduler and cache.</a:t>
             </a:r>
           </a:p>
         </p:txBody>
@@ -25474,7 +25661,7 @@
                 </a:solidFill>
                 <a:latin typeface="Helvetica Neue"/>
               </a:rPr>
-              <a:t>SCHEDULE</a:t>
+              <a:t>REPAIR</a:t>
             </a:r>
           </a:p>
         </p:txBody>
@@ -25508,7 +25695,7 @@
                 </a:solidFill>
                 <a:latin typeface="Helvetica Neue"/>
               </a:rPr>
-              <a:t>Ready DAG nodes on bounded slots</a:t>
+              <a:t>Up to two fresh candidates, redacted excerpts</a:t>
             </a:r>
           </a:p>
         </p:txBody>
@@ -25586,7 +25773,7 @@
                 </a:solidFill>
                 <a:latin typeface="Helvetica Neue"/>
               </a:rPr>
-              <a:t>REUSE</a:t>
+              <a:t>DISTRIBUTE</a:t>
             </a:r>
           </a:p>
         </p:txBody>
@@ -25620,7 +25807,7 @@
                 </a:solidFill>
                 <a:latin typeface="Helvetica Neue"/>
               </a:rPr>
-              <a:t>Rehash shared cache objects</a:t>
+              <a:t>BUILD → FINALIZE on admitted workers</a:t>
             </a:r>
           </a:p>
         </p:txBody>
@@ -25698,7 +25885,7 @@
                 </a:solidFill>
                 <a:latin typeface="Helvetica Neue"/>
               </a:rPr>
-              <a:t>PACKAGE</a:t>
+              <a:t>BUILD</a:t>
             </a:r>
           </a:p>
         </p:txBody>
@@ -25732,7 +25919,7 @@
                 </a:solidFill>
                 <a:latin typeface="Helvetica Neue"/>
               </a:rPr>
-              <a:t>Construct + inspect real .deb</a:t>
+              <a:t>Elixir/Mix with checksum-pinned Hex</a:t>
             </a:r>
           </a:p>
         </p:txBody>
@@ -25810,7 +25997,7 @@
                 </a:solidFill>
                 <a:latin typeface="Helvetica Neue"/>
               </a:rPr>
-              <a:t>ACCEPT</a:t>
+              <a:t>COORDINATE</a:t>
             </a:r>
           </a:p>
         </p:txBody>
@@ -25844,7 +26031,7 @@
                 </a:solidFill>
                 <a:latin typeface="Helvetica Neue"/>
               </a:rPr>
-              <a:t>Native CLI + gRPC evidence</a:t>
+              <a:t>Forge issues and PRs by default</a:t>
             </a:r>
           </a:p>
         </p:txBody>
@@ -25925,7 +26112,7 @@
                 </a:solidFill>
                 <a:latin typeface="Helvetica Neue"/>
               </a:rPr>
-              <a:t>1.1 slices; production dispatch, LAN proof, and remote package custody remain open.</a:t>
+              <a:t>1.2 slices; production DAG dispatch, LAN cache proof, and update merging move to 1.3.</a:t>
             </a:r>
           </a:p>
         </p:txBody>
@@ -26741,7 +26928,7 @@
                 </a:solidFill>
                 <a:latin typeface="Helvetica Neue"/>
               </a:rPr>
-              <a:t>Take one demanding downstream application through installed 1.1 scheduling, cache, package, and native acceptance, then invest in production operations.</a:t>
+              <a:t>Take one demanding downstream application through installed 1.2 repair, cross-host workers, cache, and native acceptance, then invest in production operations.</a:t>
             </a:r>
           </a:p>
         </p:txBody>
@@ -27202,7 +27389,7 @@
                 </a:solidFill>
                 <a:latin typeface="Helvetica Neue"/>
               </a:rPr>
-              <a:t>Decision: fund hardening and select one 1.1 production adopter.</a:t>
+              <a:t>Decision: fund hardening and select one 1.2 production adopter.</a:t>
             </a:r>
           </a:p>
         </p:txBody>
@@ -29176,7 +29363,7 @@
                 </a:solidFill>
                 <a:latin typeface="Helvetica Neue"/>
               </a:rPr>
-              <a:t>5</a:t>
+              <a:t>6</a:t>
             </a:r>
           </a:p>
         </p:txBody>

</xml_diff>

<commit_message>
Tighten 1.2.0 document-pair repair and update claims; legible slide 23 header
Independent review of 041b3f09. litai rebuild's repair prompt carries a bounded,
sanitized failure fact, not a raw excerpt; the redacted diagnostic excerpt is a
conformance-harness record, so slide 23 and the specs no longer conflate them.
litai update --apply exists in 1.2, so the deferred-#2 wording now says conflict
review is plan-only and apply preserves conflicts. Slide 18 notes scope Debian
construction to compatible Linux hosts. Slide 23 gains a header wash so its title
and subtitle stay legible over the photograph. Acceptance re-passes 11/11
(26 slides, 73 headings); recorded digests updated.

Co-Authored-By: Claude Opus 5.5 <noreply@anthropic.com>
</commit_message>
<xml_diff>
--- a/docs/presentations/literate-ai-manager-overview/literate-ai-manager-and-engineering-overview.pptx
+++ b/docs/presentations/literate-ai-manager-overview/literate-ai-manager-and-engineering-overview.pptx
@@ -1257,7 +1257,7 @@
           </a:p>
           <a:p>
             <a:r>
-              <a:t>Package plan is read-only. Package build reruns the accepted Standard lifecycle before constructing selected pip, Conan, or local Debian bytes beneath OBJ_DIR; package verify independently reopens them. None of these verbs publishes.</a:t>
+              <a:t>Package plan is read-only. Package build reruns the accepted Standard lifecycle before constructing selected pip, Conan, or (on compatible Linux hosts) Debian bytes beneath OBJ_DIR; package verify independently reopens them. None of these verbs publishes.</a:t>
             </a:r>
           </a:p>
           <a:p>
@@ -1782,7 +1782,7 @@
           </a:p>
           <a:p>
             <a:r>
-              <a:t>REPAIR: litai rebuild turns a retryable build or generated-test rejection into up to two fresh replacement candidates, each a durable attempt chained to the rejected one. The conformance sample runner retains a bounded, redacted diagnostic excerpt and feeds it to the next attempt. Authority: src/literate_ai/adapters/candidate_repair.py and tests/conformance/support/sample_runner.py.</a:t>
+              <a:t>REPAIR: litai rebuild turns a retryable build or generated-test rejection into up to two fresh replacement candidates, each a durable attempt chained to the rejected one. The repair prompt carries only a bounded, sanitized failure fact; separately, the conformance sample runner retains a bounded, redacted diagnostic excerpt in its evidence and next-attempt feedback. Authority: src/literate_ai/adapters/candidate_repair.py and tests/conformance/support/sample_runner.py.</a:t>
             </a:r>
           </a:p>
           <a:p>
@@ -1802,7 +1802,7 @@
           </a:p>
           <a:p>
             <a:r>
-              <a:t>Deferred to 1.3 by maintainer decision: production action-DAG dispatch with multi-worker shared LAN-cache qualification (#4) and clean three-way update merging (#2). Remote native-package custody, complete native-CLI lifecycle proof, and audited legacy-worktree retirement also remain open.</a:t>
+              <a:t>Deferred to 1.3 by maintainer decision: production action-DAG dispatch with multi-worker shared LAN-cache qualification (#4) and clean three-way update merging with reviewed resolution application (#2); in 1.2, conflict review is plan-only and update apply preserves conflicts. Remote native-package custody, complete native-CLI lifecycle proof, and audited legacy-worktree retirement also remain open.</a:t>
             </a:r>
           </a:p>
         </p:txBody>
@@ -25362,22 +25362,22 @@
       </p:sp>
       <p:sp>
         <p:nvSpPr>
-          <p:cNvPr id="5" name="Rounded Rectangle 4"/>
+          <p:cNvPr id="5" name="Rectangle 4"/>
           <p:cNvSpPr/>
           <p:nvPr/>
         </p:nvSpPr>
         <p:spPr>
           <a:xfrm>
-            <a:off x="666750" y="266700"/>
-            <a:ext cx="1257300" cy="304800"/>
-          </a:xfrm>
-          <a:prstGeom prst="roundRect">
-            <a:avLst>
-              <a:gd name="adj" fmla="val 50000"/>
-            </a:avLst>
-          </a:prstGeom>
-          <a:solidFill>
-            <a:srgbClr val="FFFFFF"/>
+            <a:off x="6667500" y="0"/>
+            <a:ext cx="5524500" cy="2400300"/>
+          </a:xfrm>
+          <a:prstGeom prst="rect">
+            <a:avLst/>
+          </a:prstGeom>
+          <a:solidFill>
+            <a:srgbClr val="101317">
+              <a:alpha val="62000"/>
+            </a:srgbClr>
           </a:solidFill>
           <a:ln>
             <a:noFill/>
@@ -25408,158 +25408,22 @@
       </p:sp>
       <p:sp>
         <p:nvSpPr>
-          <p:cNvPr id="6" name="TextBox 5"/>
-          <p:cNvSpPr txBox="1"/>
-          <p:nvPr/>
-        </p:nvSpPr>
-        <p:spPr>
-          <a:xfrm>
-            <a:off x="762000" y="323850"/>
-            <a:ext cx="1066800" cy="190500"/>
-          </a:xfrm>
-          <a:prstGeom prst="rect">
-            <a:avLst/>
-          </a:prstGeom>
-          <a:noFill/>
-        </p:spPr>
-        <p:txBody>
-          <a:bodyPr wrap="square" anchor="t" lIns="0" rIns="0" tIns="0" bIns="0">
-            <a:normAutofit/>
-          </a:bodyPr>
-          <a:lstStyle/>
-          <a:p>
-            <a:pPr algn="ctr"/>
-            <a:r>
-              <a:rPr sz="1300" b="1" i="0">
-                <a:solidFill>
-                  <a:srgbClr val="101317"/>
-                </a:solidFill>
-                <a:latin typeface="Helvetica Neue"/>
-              </a:rPr>
-              <a:t>LITERATE-AI</a:t>
-            </a:r>
-          </a:p>
-        </p:txBody>
-      </p:sp>
-      <p:sp>
-        <p:nvSpPr>
-          <p:cNvPr id="7" name="TextBox 6"/>
-          <p:cNvSpPr txBox="1"/>
-          <p:nvPr/>
-        </p:nvSpPr>
-        <p:spPr>
-          <a:xfrm>
-            <a:off x="11144250" y="304800"/>
-            <a:ext cx="381000" cy="209550"/>
-          </a:xfrm>
-          <a:prstGeom prst="rect">
-            <a:avLst/>
-          </a:prstGeom>
-          <a:noFill/>
-        </p:spPr>
-        <p:txBody>
-          <a:bodyPr wrap="square" anchor="t" lIns="0" rIns="0" tIns="0" bIns="0">
-            <a:spAutoFit/>
-          </a:bodyPr>
-          <a:lstStyle/>
-          <a:p>
-            <a:pPr algn="r"/>
-            <a:r>
-              <a:rPr sz="1300" b="1" i="0">
-                <a:solidFill>
-                  <a:srgbClr val="FFFFFF"/>
-                </a:solidFill>
-                <a:latin typeface="Helvetica Neue"/>
-              </a:rPr>
-              <a:t>23</a:t>
-            </a:r>
-          </a:p>
-        </p:txBody>
-      </p:sp>
-      <p:sp>
-        <p:nvSpPr>
-          <p:cNvPr id="8" name="TextBox 7"/>
-          <p:cNvSpPr txBox="1"/>
-          <p:nvPr/>
-        </p:nvSpPr>
-        <p:spPr>
-          <a:xfrm>
-            <a:off x="666750" y="742950"/>
-            <a:ext cx="10858500" cy="800100"/>
-          </a:xfrm>
-          <a:prstGeom prst="rect">
-            <a:avLst/>
-          </a:prstGeom>
-          <a:noFill/>
-        </p:spPr>
-        <p:txBody>
-          <a:bodyPr wrap="square" anchor="t" lIns="0" rIns="0" tIns="0" bIns="0">
-            <a:normAutofit/>
-          </a:bodyPr>
-          <a:lstStyle/>
-          <a:p>
-            <a:r>
-              <a:rPr sz="3200" b="1" i="0">
-                <a:solidFill>
-                  <a:srgbClr val="FFFFFF"/>
-                </a:solidFill>
-                <a:latin typeface="Helvetica Neue"/>
-              </a:rPr>
-              <a:t>1.2 distributes exact work and bounds candidate repair.</a:t>
-            </a:r>
-          </a:p>
-        </p:txBody>
-      </p:sp>
-      <p:sp>
-        <p:nvSpPr>
-          <p:cNvPr id="9" name="TextBox 8"/>
-          <p:cNvSpPr txBox="1"/>
-          <p:nvPr/>
-        </p:nvSpPr>
-        <p:spPr>
-          <a:xfrm>
-            <a:off x="685800" y="1600200"/>
-            <a:ext cx="10477500" cy="647700"/>
-          </a:xfrm>
-          <a:prstGeom prst="rect">
-            <a:avLst/>
-          </a:prstGeom>
-          <a:noFill/>
-        </p:spPr>
-        <p:txBody>
-          <a:bodyPr wrap="square" anchor="t" lIns="0" rIns="0" tIns="0" bIns="0">
-            <a:normAutofit/>
-          </a:bodyPr>
-          <a:lstStyle/>
-          <a:p>
-            <a:r>
-              <a:rPr sz="1700" b="0" i="0">
-                <a:solidFill>
-                  <a:srgbClr val="AAB3BC"/>
-                </a:solidFill>
-                <a:latin typeface="Helvetica Neue"/>
-              </a:rPr>
-              <a:t>Candidate repair, cross-host action workers, native Mix builds, and forge coordination build on the 1.1 scheduler and cache.</a:t>
-            </a:r>
-          </a:p>
-        </p:txBody>
-      </p:sp>
-      <p:sp>
-        <p:nvSpPr>
-          <p:cNvPr id="10" name="Rectangle 9"/>
+          <p:cNvPr id="6" name="Rounded Rectangle 5"/>
           <p:cNvSpPr/>
           <p:nvPr/>
         </p:nvSpPr>
         <p:spPr>
           <a:xfrm>
-            <a:off x="666750" y="2362200"/>
-            <a:ext cx="838200" cy="57150"/>
-          </a:xfrm>
-          <a:prstGeom prst="rect">
-            <a:avLst/>
-          </a:prstGeom>
-          <a:solidFill>
-            <a:srgbClr val="FF6B35"/>
+            <a:off x="666750" y="266700"/>
+            <a:ext cx="1257300" cy="304800"/>
+          </a:xfrm>
+          <a:prstGeom prst="roundRect">
+            <a:avLst>
+              <a:gd name="adj" fmla="val 50000"/>
+            </a:avLst>
+          </a:prstGeom>
+          <a:solidFill>
+            <a:srgbClr val="FFFFFF"/>
           </a:solidFill>
           <a:ln>
             <a:noFill/>
@@ -25590,20 +25454,158 @@
       </p:sp>
       <p:sp>
         <p:nvSpPr>
+          <p:cNvPr id="7" name="TextBox 6"/>
+          <p:cNvSpPr txBox="1"/>
+          <p:nvPr/>
+        </p:nvSpPr>
+        <p:spPr>
+          <a:xfrm>
+            <a:off x="762000" y="323850"/>
+            <a:ext cx="1066800" cy="190500"/>
+          </a:xfrm>
+          <a:prstGeom prst="rect">
+            <a:avLst/>
+          </a:prstGeom>
+          <a:noFill/>
+        </p:spPr>
+        <p:txBody>
+          <a:bodyPr wrap="square" anchor="t" lIns="0" rIns="0" tIns="0" bIns="0">
+            <a:normAutofit/>
+          </a:bodyPr>
+          <a:lstStyle/>
+          <a:p>
+            <a:pPr algn="ctr"/>
+            <a:r>
+              <a:rPr sz="1300" b="1" i="0">
+                <a:solidFill>
+                  <a:srgbClr val="101317"/>
+                </a:solidFill>
+                <a:latin typeface="Helvetica Neue"/>
+              </a:rPr>
+              <a:t>LITERATE-AI</a:t>
+            </a:r>
+          </a:p>
+        </p:txBody>
+      </p:sp>
+      <p:sp>
+        <p:nvSpPr>
+          <p:cNvPr id="8" name="TextBox 7"/>
+          <p:cNvSpPr txBox="1"/>
+          <p:nvPr/>
+        </p:nvSpPr>
+        <p:spPr>
+          <a:xfrm>
+            <a:off x="11144250" y="304800"/>
+            <a:ext cx="381000" cy="209550"/>
+          </a:xfrm>
+          <a:prstGeom prst="rect">
+            <a:avLst/>
+          </a:prstGeom>
+          <a:noFill/>
+        </p:spPr>
+        <p:txBody>
+          <a:bodyPr wrap="square" anchor="t" lIns="0" rIns="0" tIns="0" bIns="0">
+            <a:spAutoFit/>
+          </a:bodyPr>
+          <a:lstStyle/>
+          <a:p>
+            <a:pPr algn="r"/>
+            <a:r>
+              <a:rPr sz="1300" b="1" i="0">
+                <a:solidFill>
+                  <a:srgbClr val="FFFFFF"/>
+                </a:solidFill>
+                <a:latin typeface="Helvetica Neue"/>
+              </a:rPr>
+              <a:t>23</a:t>
+            </a:r>
+          </a:p>
+        </p:txBody>
+      </p:sp>
+      <p:sp>
+        <p:nvSpPr>
+          <p:cNvPr id="9" name="TextBox 8"/>
+          <p:cNvSpPr txBox="1"/>
+          <p:nvPr/>
+        </p:nvSpPr>
+        <p:spPr>
+          <a:xfrm>
+            <a:off x="666750" y="742950"/>
+            <a:ext cx="10858500" cy="800100"/>
+          </a:xfrm>
+          <a:prstGeom prst="rect">
+            <a:avLst/>
+          </a:prstGeom>
+          <a:noFill/>
+        </p:spPr>
+        <p:txBody>
+          <a:bodyPr wrap="square" anchor="t" lIns="0" rIns="0" tIns="0" bIns="0">
+            <a:normAutofit/>
+          </a:bodyPr>
+          <a:lstStyle/>
+          <a:p>
+            <a:r>
+              <a:rPr sz="3200" b="1" i="0">
+                <a:solidFill>
+                  <a:srgbClr val="FFFFFF"/>
+                </a:solidFill>
+                <a:latin typeface="Helvetica Neue"/>
+              </a:rPr>
+              <a:t>1.2 distributes exact work and bounds candidate repair.</a:t>
+            </a:r>
+          </a:p>
+        </p:txBody>
+      </p:sp>
+      <p:sp>
+        <p:nvSpPr>
+          <p:cNvPr id="10" name="TextBox 9"/>
+          <p:cNvSpPr txBox="1"/>
+          <p:nvPr/>
+        </p:nvSpPr>
+        <p:spPr>
+          <a:xfrm>
+            <a:off x="685800" y="1600200"/>
+            <a:ext cx="10477500" cy="647700"/>
+          </a:xfrm>
+          <a:prstGeom prst="rect">
+            <a:avLst/>
+          </a:prstGeom>
+          <a:noFill/>
+        </p:spPr>
+        <p:txBody>
+          <a:bodyPr wrap="square" anchor="t" lIns="0" rIns="0" tIns="0" bIns="0">
+            <a:normAutofit/>
+          </a:bodyPr>
+          <a:lstStyle/>
+          <a:p>
+            <a:r>
+              <a:rPr sz="1700" b="0" i="0">
+                <a:solidFill>
+                  <a:srgbClr val="AAB3BC"/>
+                </a:solidFill>
+                <a:latin typeface="Helvetica Neue"/>
+              </a:rPr>
+              <a:t>Candidate repair, cross-host action workers, native Mix builds, and forge coordination build on the 1.1 scheduler and cache.</a:t>
+            </a:r>
+          </a:p>
+        </p:txBody>
+      </p:sp>
+      <p:sp>
+        <p:nvSpPr>
           <p:cNvPr id="11" name="Rectangle 10"/>
           <p:cNvSpPr/>
           <p:nvPr/>
         </p:nvSpPr>
         <p:spPr>
           <a:xfrm>
-            <a:off x="666750" y="2590800"/>
-            <a:ext cx="76200" cy="609600"/>
-          </a:xfrm>
-          <a:prstGeom prst="rect">
-            <a:avLst/>
-          </a:prstGeom>
-          <a:solidFill>
-            <a:srgbClr val="7BC6A4"/>
+            <a:off x="666750" y="2362200"/>
+            <a:ext cx="838200" cy="57150"/>
+          </a:xfrm>
+          <a:prstGeom prst="rect">
+            <a:avLst/>
+          </a:prstGeom>
+          <a:solidFill>
+            <a:srgbClr val="FF6B35"/>
           </a:solidFill>
           <a:ln>
             <a:noFill/>
@@ -25634,88 +25636,20 @@
       </p:sp>
       <p:sp>
         <p:nvSpPr>
-          <p:cNvPr id="12" name="TextBox 11"/>
-          <p:cNvSpPr txBox="1"/>
-          <p:nvPr/>
-        </p:nvSpPr>
-        <p:spPr>
-          <a:xfrm>
-            <a:off x="914400" y="2590800"/>
-            <a:ext cx="4572000" cy="247650"/>
-          </a:xfrm>
-          <a:prstGeom prst="rect">
-            <a:avLst/>
-          </a:prstGeom>
-          <a:noFill/>
-        </p:spPr>
-        <p:txBody>
-          <a:bodyPr wrap="square" anchor="t" lIns="0" rIns="0" tIns="0" bIns="0">
-            <a:spAutoFit/>
-          </a:bodyPr>
-          <a:lstStyle/>
-          <a:p>
-            <a:r>
-              <a:rPr sz="1800" b="1" i="0">
-                <a:solidFill>
-                  <a:srgbClr val="FFFFFF"/>
-                </a:solidFill>
-                <a:latin typeface="Helvetica Neue"/>
-              </a:rPr>
-              <a:t>REPAIR</a:t>
-            </a:r>
-          </a:p>
-        </p:txBody>
-      </p:sp>
-      <p:sp>
-        <p:nvSpPr>
-          <p:cNvPr id="13" name="TextBox 12"/>
-          <p:cNvSpPr txBox="1"/>
-          <p:nvPr/>
-        </p:nvSpPr>
-        <p:spPr>
-          <a:xfrm>
-            <a:off x="914400" y="2857500"/>
-            <a:ext cx="4572000" cy="266700"/>
-          </a:xfrm>
-          <a:prstGeom prst="rect">
-            <a:avLst/>
-          </a:prstGeom>
-          <a:noFill/>
-        </p:spPr>
-        <p:txBody>
-          <a:bodyPr wrap="square" anchor="t" lIns="0" rIns="0" tIns="0" bIns="0">
-            <a:spAutoFit/>
-          </a:bodyPr>
-          <a:lstStyle/>
-          <a:p>
-            <a:r>
-              <a:rPr sz="1500" b="0" i="0">
-                <a:solidFill>
-                  <a:srgbClr val="EEF1F3"/>
-                </a:solidFill>
-                <a:latin typeface="Helvetica Neue"/>
-              </a:rPr>
-              <a:t>Up to two fresh candidates, redacted excerpts</a:t>
-            </a:r>
-          </a:p>
-        </p:txBody>
-      </p:sp>
-      <p:sp>
-        <p:nvSpPr>
-          <p:cNvPr id="14" name="Rectangle 13"/>
+          <p:cNvPr id="12" name="Rectangle 11"/>
           <p:cNvSpPr/>
           <p:nvPr/>
         </p:nvSpPr>
         <p:spPr>
           <a:xfrm>
-            <a:off x="666750" y="3352800"/>
+            <a:off x="666750" y="2590800"/>
             <a:ext cx="76200" cy="609600"/>
           </a:xfrm>
           <a:prstGeom prst="rect">
             <a:avLst/>
           </a:prstGeom>
           <a:solidFill>
-            <a:srgbClr val="FF6B35"/>
+            <a:srgbClr val="7BC6A4"/>
           </a:solidFill>
           <a:ln>
             <a:noFill/>
@@ -25746,13 +25680,13 @@
       </p:sp>
       <p:sp>
         <p:nvSpPr>
-          <p:cNvPr id="15" name="TextBox 14"/>
+          <p:cNvPr id="13" name="TextBox 12"/>
           <p:cNvSpPr txBox="1"/>
           <p:nvPr/>
         </p:nvSpPr>
         <p:spPr>
           <a:xfrm>
-            <a:off x="914400" y="3352800"/>
+            <a:off x="914400" y="2590800"/>
             <a:ext cx="4572000" cy="247650"/>
           </a:xfrm>
           <a:prstGeom prst="rect">
@@ -25773,20 +25707,20 @@
                 </a:solidFill>
                 <a:latin typeface="Helvetica Neue"/>
               </a:rPr>
-              <a:t>DISTRIBUTE</a:t>
-            </a:r>
-          </a:p>
-        </p:txBody>
-      </p:sp>
-      <p:sp>
-        <p:nvSpPr>
-          <p:cNvPr id="16" name="TextBox 15"/>
+              <a:t>REPAIR</a:t>
+            </a:r>
+          </a:p>
+        </p:txBody>
+      </p:sp>
+      <p:sp>
+        <p:nvSpPr>
+          <p:cNvPr id="14" name="TextBox 13"/>
           <p:cNvSpPr txBox="1"/>
           <p:nvPr/>
         </p:nvSpPr>
         <p:spPr>
           <a:xfrm>
-            <a:off x="914400" y="3619500"/>
+            <a:off x="914400" y="2857500"/>
             <a:ext cx="4572000" cy="266700"/>
           </a:xfrm>
           <a:prstGeom prst="rect">
@@ -25807,20 +25741,20 @@
                 </a:solidFill>
                 <a:latin typeface="Helvetica Neue"/>
               </a:rPr>
-              <a:t>BUILD → FINALIZE on admitted workers</a:t>
-            </a:r>
-          </a:p>
-        </p:txBody>
-      </p:sp>
-      <p:sp>
-        <p:nvSpPr>
-          <p:cNvPr id="17" name="Rectangle 16"/>
+              <a:t>Up to two fresh replacement candidates</a:t>
+            </a:r>
+          </a:p>
+        </p:txBody>
+      </p:sp>
+      <p:sp>
+        <p:nvSpPr>
+          <p:cNvPr id="15" name="Rectangle 14"/>
           <p:cNvSpPr/>
           <p:nvPr/>
         </p:nvSpPr>
         <p:spPr>
           <a:xfrm>
-            <a:off x="666750" y="4114800"/>
+            <a:off x="666750" y="3352800"/>
             <a:ext cx="76200" cy="609600"/>
           </a:xfrm>
           <a:prstGeom prst="rect">
@@ -25858,13 +25792,13 @@
       </p:sp>
       <p:sp>
         <p:nvSpPr>
-          <p:cNvPr id="18" name="TextBox 17"/>
+          <p:cNvPr id="16" name="TextBox 15"/>
           <p:cNvSpPr txBox="1"/>
           <p:nvPr/>
         </p:nvSpPr>
         <p:spPr>
           <a:xfrm>
-            <a:off x="914400" y="4114800"/>
+            <a:off x="914400" y="3352800"/>
             <a:ext cx="4572000" cy="247650"/>
           </a:xfrm>
           <a:prstGeom prst="rect">
@@ -25885,20 +25819,20 @@
                 </a:solidFill>
                 <a:latin typeface="Helvetica Neue"/>
               </a:rPr>
-              <a:t>BUILD</a:t>
-            </a:r>
-          </a:p>
-        </p:txBody>
-      </p:sp>
-      <p:sp>
-        <p:nvSpPr>
-          <p:cNvPr id="19" name="TextBox 18"/>
+              <a:t>DISTRIBUTE</a:t>
+            </a:r>
+          </a:p>
+        </p:txBody>
+      </p:sp>
+      <p:sp>
+        <p:nvSpPr>
+          <p:cNvPr id="17" name="TextBox 16"/>
           <p:cNvSpPr txBox="1"/>
           <p:nvPr/>
         </p:nvSpPr>
         <p:spPr>
           <a:xfrm>
-            <a:off x="914400" y="4381500"/>
+            <a:off x="914400" y="3619500"/>
             <a:ext cx="4572000" cy="266700"/>
           </a:xfrm>
           <a:prstGeom prst="rect">
@@ -25919,20 +25853,20 @@
                 </a:solidFill>
                 <a:latin typeface="Helvetica Neue"/>
               </a:rPr>
-              <a:t>Elixir/Mix with checksum-pinned Hex</a:t>
-            </a:r>
-          </a:p>
-        </p:txBody>
-      </p:sp>
-      <p:sp>
-        <p:nvSpPr>
-          <p:cNvPr id="20" name="Rectangle 19"/>
+              <a:t>BUILD → FINALIZE on admitted workers</a:t>
+            </a:r>
+          </a:p>
+        </p:txBody>
+      </p:sp>
+      <p:sp>
+        <p:nvSpPr>
+          <p:cNvPr id="18" name="Rectangle 17"/>
           <p:cNvSpPr/>
           <p:nvPr/>
         </p:nvSpPr>
         <p:spPr>
           <a:xfrm>
-            <a:off x="666750" y="4876800"/>
+            <a:off x="666750" y="4114800"/>
             <a:ext cx="76200" cy="609600"/>
           </a:xfrm>
           <a:prstGeom prst="rect">
@@ -25970,13 +25904,13 @@
       </p:sp>
       <p:sp>
         <p:nvSpPr>
-          <p:cNvPr id="21" name="TextBox 20"/>
+          <p:cNvPr id="19" name="TextBox 18"/>
           <p:cNvSpPr txBox="1"/>
           <p:nvPr/>
         </p:nvSpPr>
         <p:spPr>
           <a:xfrm>
-            <a:off x="914400" y="4876800"/>
+            <a:off x="914400" y="4114800"/>
             <a:ext cx="4572000" cy="247650"/>
           </a:xfrm>
           <a:prstGeom prst="rect">
@@ -25997,20 +25931,20 @@
                 </a:solidFill>
                 <a:latin typeface="Helvetica Neue"/>
               </a:rPr>
-              <a:t>COORDINATE</a:t>
-            </a:r>
-          </a:p>
-        </p:txBody>
-      </p:sp>
-      <p:sp>
-        <p:nvSpPr>
-          <p:cNvPr id="22" name="TextBox 21"/>
+              <a:t>BUILD</a:t>
+            </a:r>
+          </a:p>
+        </p:txBody>
+      </p:sp>
+      <p:sp>
+        <p:nvSpPr>
+          <p:cNvPr id="20" name="TextBox 19"/>
           <p:cNvSpPr txBox="1"/>
           <p:nvPr/>
         </p:nvSpPr>
         <p:spPr>
           <a:xfrm>
-            <a:off x="914400" y="5143500"/>
+            <a:off x="914400" y="4381500"/>
             <a:ext cx="4572000" cy="266700"/>
           </a:xfrm>
           <a:prstGeom prst="rect">
@@ -26031,29 +25965,27 @@
                 </a:solidFill>
                 <a:latin typeface="Helvetica Neue"/>
               </a:rPr>
-              <a:t>Forge issues and PRs by default</a:t>
-            </a:r>
-          </a:p>
-        </p:txBody>
-      </p:sp>
-      <p:sp>
-        <p:nvSpPr>
-          <p:cNvPr id="23" name="Rounded Rectangle 22"/>
+              <a:t>Elixir/Mix with checksum-pinned Hex</a:t>
+            </a:r>
+          </a:p>
+        </p:txBody>
+      </p:sp>
+      <p:sp>
+        <p:nvSpPr>
+          <p:cNvPr id="21" name="Rectangle 20"/>
           <p:cNvSpPr/>
           <p:nvPr/>
         </p:nvSpPr>
         <p:spPr>
           <a:xfrm>
-            <a:off x="666750" y="6172200"/>
-            <a:ext cx="10858500" cy="342900"/>
-          </a:xfrm>
-          <a:prstGeom prst="roundRect">
-            <a:avLst>
-              <a:gd name="adj" fmla="val 50000"/>
-            </a:avLst>
-          </a:prstGeom>
-          <a:solidFill>
-            <a:srgbClr val="1A1F26"/>
+            <a:off x="666750" y="4876800"/>
+            <a:ext cx="76200" cy="609600"/>
+          </a:xfrm>
+          <a:prstGeom prst="rect">
+            <a:avLst/>
+          </a:prstGeom>
+          <a:solidFill>
+            <a:srgbClr val="FF6B35"/>
           </a:solidFill>
           <a:ln>
             <a:noFill/>
@@ -26084,49 +26016,14 @@
       </p:sp>
       <p:sp>
         <p:nvSpPr>
-          <p:cNvPr id="24" name="TextBox 23"/>
+          <p:cNvPr id="22" name="TextBox 21"/>
           <p:cNvSpPr txBox="1"/>
           <p:nvPr/>
         </p:nvSpPr>
         <p:spPr>
           <a:xfrm>
-            <a:off x="857250" y="6248400"/>
-            <a:ext cx="10477500" cy="209550"/>
-          </a:xfrm>
-          <a:prstGeom prst="rect">
-            <a:avLst/>
-          </a:prstGeom>
-          <a:noFill/>
-        </p:spPr>
-        <p:txBody>
-          <a:bodyPr wrap="square" anchor="t" lIns="0" rIns="0" tIns="0" bIns="0">
-            <a:normAutofit/>
-          </a:bodyPr>
-          <a:lstStyle/>
-          <a:p>
-            <a:pPr algn="ctr"/>
-            <a:r>
-              <a:rPr sz="1300" b="1" i="0">
-                <a:solidFill>
-                  <a:srgbClr val="FF9B66"/>
-                </a:solidFill>
-                <a:latin typeface="Helvetica Neue"/>
-              </a:rPr>
-              <a:t>1.2 slices; production DAG dispatch, LAN cache proof, and update merging move to 1.3.</a:t>
-            </a:r>
-          </a:p>
-        </p:txBody>
-      </p:sp>
-      <p:sp>
-        <p:nvSpPr>
-          <p:cNvPr id="25" name="TextBox 24"/>
-          <p:cNvSpPr txBox="1"/>
-          <p:nvPr/>
-        </p:nvSpPr>
-        <p:spPr>
-          <a:xfrm>
-            <a:off x="666750" y="6648450"/>
-            <a:ext cx="1428750" cy="152400"/>
+            <a:off x="914400" y="4876800"/>
+            <a:ext cx="4572000" cy="247650"/>
           </a:xfrm>
           <a:prstGeom prst="rect">
             <a:avLst/>
@@ -26140,33 +26037,69 @@
           <a:lstStyle/>
           <a:p>
             <a:r>
-              <a:rPr sz="1100" b="1" i="0">
-                <a:solidFill>
-                  <a:srgbClr val="AAB3BC"/>
-                </a:solidFill>
-                <a:latin typeface="Helvetica Neue"/>
-              </a:rPr>
-              <a:t>LITERATE-AI</a:t>
-            </a:r>
-          </a:p>
-        </p:txBody>
-      </p:sp>
-      <p:sp>
-        <p:nvSpPr>
-          <p:cNvPr id="26" name="Rectangle 25"/>
+              <a:rPr sz="1800" b="1" i="0">
+                <a:solidFill>
+                  <a:srgbClr val="FFFFFF"/>
+                </a:solidFill>
+                <a:latin typeface="Helvetica Neue"/>
+              </a:rPr>
+              <a:t>COORDINATE</a:t>
+            </a:r>
+          </a:p>
+        </p:txBody>
+      </p:sp>
+      <p:sp>
+        <p:nvSpPr>
+          <p:cNvPr id="23" name="TextBox 22"/>
+          <p:cNvSpPr txBox="1"/>
+          <p:nvPr/>
+        </p:nvSpPr>
+        <p:spPr>
+          <a:xfrm>
+            <a:off x="914400" y="5143500"/>
+            <a:ext cx="4572000" cy="266700"/>
+          </a:xfrm>
+          <a:prstGeom prst="rect">
+            <a:avLst/>
+          </a:prstGeom>
+          <a:noFill/>
+        </p:spPr>
+        <p:txBody>
+          <a:bodyPr wrap="square" anchor="t" lIns="0" rIns="0" tIns="0" bIns="0">
+            <a:spAutoFit/>
+          </a:bodyPr>
+          <a:lstStyle/>
+          <a:p>
+            <a:r>
+              <a:rPr sz="1500" b="0" i="0">
+                <a:solidFill>
+                  <a:srgbClr val="EEF1F3"/>
+                </a:solidFill>
+                <a:latin typeface="Helvetica Neue"/>
+              </a:rPr>
+              <a:t>Forge issues and PRs by default</a:t>
+            </a:r>
+          </a:p>
+        </p:txBody>
+      </p:sp>
+      <p:sp>
+        <p:nvSpPr>
+          <p:cNvPr id="24" name="Rounded Rectangle 23"/>
           <p:cNvSpPr/>
           <p:nvPr/>
         </p:nvSpPr>
         <p:spPr>
           <a:xfrm>
-            <a:off x="10287000" y="6705600"/>
-            <a:ext cx="1143000" cy="28575"/>
-          </a:xfrm>
-          <a:prstGeom prst="rect">
-            <a:avLst/>
-          </a:prstGeom>
-          <a:solidFill>
-            <a:srgbClr val="23282F"/>
+            <a:off x="666750" y="6172200"/>
+            <a:ext cx="10858500" cy="342900"/>
+          </a:xfrm>
+          <a:prstGeom prst="roundRect">
+            <a:avLst>
+              <a:gd name="adj" fmla="val 50000"/>
+            </a:avLst>
+          </a:prstGeom>
+          <a:solidFill>
+            <a:srgbClr val="1A1F26"/>
           </a:solidFill>
           <a:ln>
             <a:noFill/>
@@ -26197,7 +26130,120 @@
       </p:sp>
       <p:sp>
         <p:nvSpPr>
+          <p:cNvPr id="25" name="TextBox 24"/>
+          <p:cNvSpPr txBox="1"/>
+          <p:nvPr/>
+        </p:nvSpPr>
+        <p:spPr>
+          <a:xfrm>
+            <a:off x="857250" y="6248400"/>
+            <a:ext cx="10477500" cy="209550"/>
+          </a:xfrm>
+          <a:prstGeom prst="rect">
+            <a:avLst/>
+          </a:prstGeom>
+          <a:noFill/>
+        </p:spPr>
+        <p:txBody>
+          <a:bodyPr wrap="square" anchor="t" lIns="0" rIns="0" tIns="0" bIns="0">
+            <a:normAutofit/>
+          </a:bodyPr>
+          <a:lstStyle/>
+          <a:p>
+            <a:pPr algn="ctr"/>
+            <a:r>
+              <a:rPr sz="1300" b="1" i="0">
+                <a:solidFill>
+                  <a:srgbClr val="FF9B66"/>
+                </a:solidFill>
+                <a:latin typeface="Helvetica Neue"/>
+              </a:rPr>
+              <a:t>1.2 slices; production DAG dispatch, LAN cache proof, and clean update merging move to 1.3.</a:t>
+            </a:r>
+          </a:p>
+        </p:txBody>
+      </p:sp>
+      <p:sp>
+        <p:nvSpPr>
+          <p:cNvPr id="26" name="TextBox 25"/>
+          <p:cNvSpPr txBox="1"/>
+          <p:nvPr/>
+        </p:nvSpPr>
+        <p:spPr>
+          <a:xfrm>
+            <a:off x="666750" y="6648450"/>
+            <a:ext cx="1428750" cy="152400"/>
+          </a:xfrm>
+          <a:prstGeom prst="rect">
+            <a:avLst/>
+          </a:prstGeom>
+          <a:noFill/>
+        </p:spPr>
+        <p:txBody>
+          <a:bodyPr wrap="square" anchor="t" lIns="0" rIns="0" tIns="0" bIns="0">
+            <a:spAutoFit/>
+          </a:bodyPr>
+          <a:lstStyle/>
+          <a:p>
+            <a:r>
+              <a:rPr sz="1100" b="1" i="0">
+                <a:solidFill>
+                  <a:srgbClr val="AAB3BC"/>
+                </a:solidFill>
+                <a:latin typeface="Helvetica Neue"/>
+              </a:rPr>
+              <a:t>LITERATE-AI</a:t>
+            </a:r>
+          </a:p>
+        </p:txBody>
+      </p:sp>
+      <p:sp>
+        <p:nvSpPr>
           <p:cNvPr id="27" name="Rectangle 26"/>
+          <p:cNvSpPr/>
+          <p:nvPr/>
+        </p:nvSpPr>
+        <p:spPr>
+          <a:xfrm>
+            <a:off x="10287000" y="6705600"/>
+            <a:ext cx="1143000" cy="28575"/>
+          </a:xfrm>
+          <a:prstGeom prst="rect">
+            <a:avLst/>
+          </a:prstGeom>
+          <a:solidFill>
+            <a:srgbClr val="23282F"/>
+          </a:solidFill>
+          <a:ln>
+            <a:noFill/>
+          </a:ln>
+          <a:effectLst/>
+        </p:spPr>
+        <p:style>
+          <a:lnRef idx="1">
+            <a:schemeClr val="accent1"/>
+          </a:lnRef>
+          <a:fillRef idx="3">
+            <a:schemeClr val="accent1"/>
+          </a:fillRef>
+          <a:effectRef idx="2">
+            <a:schemeClr val="accent1"/>
+          </a:effectRef>
+          <a:fontRef idx="minor">
+            <a:schemeClr val="lt1"/>
+          </a:fontRef>
+        </p:style>
+        <p:txBody>
+          <a:bodyPr rtlCol="0" anchor="ctr"/>
+          <a:lstStyle/>
+          <a:p>
+            <a:pPr algn="ctr"/>
+          </a:p>
+        </p:txBody>
+      </p:sp>
+      <p:sp>
+        <p:nvSpPr>
+          <p:cNvPr id="28" name="Rectangle 27"/>
           <p:cNvSpPr/>
           <p:nvPr/>
         </p:nvSpPr>

</xml_diff>

<commit_message>
docs: prepare 1.3 release collateral
</commit_message>
<xml_diff>
--- a/docs/presentations/literate-ai-manager-overview/literate-ai-manager-and-engineering-overview.pptx
+++ b/docs/presentations/literate-ai-manager-overview/literate-ai-manager-and-engineering-overview.pptx
@@ -1522,7 +1522,7 @@
           </a:p>
           <a:p>
             <a:r>
-              <a:t>ADR 0034 adds a Python-owned contribution sweep and authenticated document-pair preflight for every major or minor cut. This slide does not claim v1.2.0 is already published.</a:t>
+              <a:t>ADR 0034 adds a Python-owned contribution sweep and authenticated document-pair preflight for every major or minor cut. This slide does not claim v1.3.0 is already published.</a:t>
             </a:r>
           </a:p>
           <a:p>
@@ -1532,7 +1532,7 @@
           </a:p>
           <a:p>
             <a:r>
-              <a:t>1.2 requires an explicit SemVer release policy. When the policy declares qualification, release check defaults to a tiered target: each platform x action cell is covered by the host running the coding CLI, then one workers.json worker per remaining platform, then CI; litai release qualify records exact-HEAD coverage.</a:t>
+              <a:t>1.3 retains the explicit SemVer release policy. When the policy declares qualification, release check defaults to a tiered target: each platform x action cell is covered by the host running the coding CLI, then one workers.json worker per remaining platform, then CI; litai release qualify records exact-HEAD coverage.</a:t>
             </a:r>
           </a:p>
         </p:txBody>
@@ -1777,32 +1777,32 @@
           <a:lstStyle/>
           <a:p>
             <a:r>
-              <a:t>The 1.1 foundation remains: dependency-aware bounded scheduling, provider-neutral cache authority, real local Debian construction, native CLI and gRPC acceptance, and canonical worktree placement, plus native custody and the 1.0 operator/release boundaries.</a:t>
-            </a:r>
-          </a:p>
-          <a:p>
-            <a:r>
-              <a:t>REPAIR: litai rebuild turns a retryable build or generated-test rejection into up to two fresh replacement candidates, each a durable attempt chained to the rejected one. The repair prompt carries only a bounded, sanitized failure fact; separately, the conformance sample runner retains a bounded, redacted diagnostic excerpt in its evidence and next-attempt feedback. Authority: src/literate_ai/adapters/candidate_repair.py and tests/conformance/support/sample_runner.py.</a:t>
-            </a:r>
-          </a:p>
-          <a:p>
-            <a:r>
-              <a:t>DISTRIBUTE: when BUILD, TEST, EXECUTE and FINALIZE all run on admitted workers, rebuild derives toolchain identities, commands and native dependencies from the worker; python -m literate_ai.standard_receiver is the reference receiver for portable single-Component Make/Python projects. Production FINALIZE grant provisioning remains pending.</a:t>
-            </a:r>
-          </a:p>
-          <a:p>
-            <a:r>
-              <a:t>BUILD: the build-mix Flavor pins each Hex package's exact version and checksums, refuses ranges, and requires the native lock to equal those pins before compiling. Mix builds are local-only in 1.2. Hex is a toolchain constraint and dependency input, not a package provider.</a:t>
-            </a:r>
-          </a:p>
-          <a:p>
-            <a:r>
-              <a:t>COORDINATE: ADR 0050 makes forge issues and PRs/MRs the default tracker and agent channel; other trackers are overrides. prompt-task@2 is the generic external envelope. Remote live gates no longer require OPENAI_API_KEY.</a:t>
-            </a:r>
-          </a:p>
-          <a:p>
-            <a:r>
-              <a:t>Deferred to 1.3 by maintainer decision: production action-DAG dispatch with multi-worker shared LAN-cache qualification (#4) and clean three-way update merging with reviewed resolution application (#2); in 1.2, conflict review is plan-only and update apply preserves conflicts. Remote native-package custody, complete native-CLI lifecycle proof, and audited legacy-worktree retirement also remain open.</a:t>
+              <a:t>The 1.2 foundation remains: bounded candidate repair, cross-host action workers, native Mix builds, forge-default coordination, tiered qualification, plus the 1.1 scheduler/cache/package/native-acceptance foundation and 1.0 operator/release boundaries.</a:t>
+            </a:r>
+          </a:p>
+          <a:p>
+            <a:r>
+              <a:t>ADOPT: reviewed first Standard binding and original-source admission preserve existing receipt policy, historical evidence, and source authority. Retained execution and downstream release admission remain separate gates.</a:t>
+            </a:r>
+          </a:p>
+          <a:p>
+            <a:r>
+              <a:t>TARGET: target-bound Python source projection keeps original source intact while binding reviewed exclusions to exact marker and lock authority. FreeBSD worker and target identities landed as development foundations, not complete platform acceptance.</a:t>
+            </a:r>
+          </a:p>
+          <a:p>
+            <a:r>
+              <a:t>CARRY: versioned SDK tree, alias, hard-link, package-plan, and topology contracts preserve exact producer and consumer custody. Decoding or relocating a tree grants no producer, package, or release admission by itself.</a:t>
+            </a:r>
+          </a:p>
+          <a:p>
+            <a:r>
+              <a:t>HARDEN: retained execution now binds Windows system context, executable intent, scoped secondary identities, runtime paths, and current installed bytes more tightly. Several native end-to-end qualifications remain deliberately deferred.</a:t>
+            </a:r>
+          </a:p>
+          <a:p>
+            <a:r>
+              <a:t>Deferred from 1.3.0: bounded diagnostics and reliability fixes move to 1.3.1; complete FreeBSD admission, Windows ARM64 realization, remote native packaging, production action-DAG/LAN-cache proof, and broader retained-project feature contracts move to 1.4.</a:t>
             </a:r>
           </a:p>
         </p:txBody>
@@ -25551,7 +25551,7 @@
                 </a:solidFill>
                 <a:latin typeface="Helvetica Neue"/>
               </a:rPr>
-              <a:t>1.2 distributes exact work and bounds candidate repair.</a:t>
+              <a:t>1.3 advances retained source and native custody.</a:t>
             </a:r>
           </a:p>
         </p:txBody>
@@ -25585,7 +25585,7 @@
                 </a:solidFill>
                 <a:latin typeface="Helvetica Neue"/>
               </a:rPr>
-              <a:t>Candidate repair, cross-host action workers, native Mix builds, and forge coordination build on the 1.1 scheduler and cache.</a:t>
+              <a:t>Reviewed original-source binding, target-bound Python projection, FreeBSD identities, and SDK tree custody build on 1.2.</a:t>
             </a:r>
           </a:p>
         </p:txBody>
@@ -25707,7 +25707,7 @@
                 </a:solidFill>
                 <a:latin typeface="Helvetica Neue"/>
               </a:rPr>
-              <a:t>REPAIR</a:t>
+              <a:t>ADOPT</a:t>
             </a:r>
           </a:p>
         </p:txBody>
@@ -25741,7 +25741,7 @@
                 </a:solidFill>
                 <a:latin typeface="Helvetica Neue"/>
               </a:rPr>
-              <a:t>Up to two fresh replacement candidates</a:t>
+              <a:t>Reviewed original-source first binding</a:t>
             </a:r>
           </a:p>
         </p:txBody>
@@ -25819,7 +25819,7 @@
                 </a:solidFill>
                 <a:latin typeface="Helvetica Neue"/>
               </a:rPr>
-              <a:t>DISTRIBUTE</a:t>
+              <a:t>TARGET</a:t>
             </a:r>
           </a:p>
         </p:txBody>
@@ -25853,7 +25853,7 @@
                 </a:solidFill>
                 <a:latin typeface="Helvetica Neue"/>
               </a:rPr>
-              <a:t>BUILD → FINALIZE on admitted workers</a:t>
+              <a:t>Python projections + FreeBSD identities</a:t>
             </a:r>
           </a:p>
         </p:txBody>
@@ -25931,7 +25931,7 @@
                 </a:solidFill>
                 <a:latin typeface="Helvetica Neue"/>
               </a:rPr>
-              <a:t>BUILD</a:t>
+              <a:t>CARRY</a:t>
             </a:r>
           </a:p>
         </p:txBody>
@@ -25965,7 +25965,7 @@
                 </a:solidFill>
                 <a:latin typeface="Helvetica Neue"/>
               </a:rPr>
-              <a:t>Elixir/Mix with checksum-pinned Hex</a:t>
+              <a:t>SDK trees, aliases, and package topology</a:t>
             </a:r>
           </a:p>
         </p:txBody>
@@ -26043,7 +26043,7 @@
                 </a:solidFill>
                 <a:latin typeface="Helvetica Neue"/>
               </a:rPr>
-              <a:t>COORDINATE</a:t>
+              <a:t>HARDEN</a:t>
             </a:r>
           </a:p>
         </p:txBody>
@@ -26077,7 +26077,7 @@
                 </a:solidFill>
                 <a:latin typeface="Helvetica Neue"/>
               </a:rPr>
-              <a:t>Forge issues and PRs by default</a:t>
+              <a:t>Retained execution and receipt boundaries</a:t>
             </a:r>
           </a:p>
         </p:txBody>
@@ -26158,7 +26158,7 @@
                 </a:solidFill>
                 <a:latin typeface="Helvetica Neue"/>
               </a:rPr>
-              <a:t>1.2 slices; production DAG dispatch, LAN cache proof, and clean update merging move to 1.3.</a:t>
+              <a:t>Landed framework slices; unfinished native and platform admission moves to 1.3.1 or 1.4.</a:t>
             </a:r>
           </a:p>
         </p:txBody>
@@ -26974,7 +26974,7 @@
                 </a:solidFill>
                 <a:latin typeface="Helvetica Neue"/>
               </a:rPr>
-              <a:t>Take one demanding downstream application through installed 1.2 repair, cross-host workers, cache, and native acceptance, then invest in production operations.</a:t>
+              <a:t>Take one demanding downstream application through installed 1.3 retained-source, worker, package, and native-custody paths, then invest in production operations.</a:t>
             </a:r>
           </a:p>
         </p:txBody>

</xml_diff>